<commit_message>
Translate pitch deck to English (HTML + PPTX)
Full English rewrite of both presentation/maninos-pitch.html and
presentation/build_pptx.py (which regenerates Maninos_OS_Pitch.pptx).
Same 19 slides, same editorial tone, same verified numbers from the
repo. Slide 7 retitled "Customers Portal" (was "Portal Clientes")
since "Clientes" doesn't translate naturally for English readers; the
internal route path /clientes is preserved as the technical reference.
</commit_message>
<xml_diff>
--- a/presentation/Maninos_OS_Pitch.pptx
+++ b/presentation/Maninos_OS_Pitch.pptx
@@ -3186,7 +3186,7 @@
                 </a:solidFill>
                 <a:latin typeface="Calibri"/>
               </a:rPr>
-              <a:t>MANINOS OS    ·    DOCUMENTO DESCRIPTIVO    ·    VERSIÓN 2026.04</a:t>
+              <a:t>MANINOS OS    ·    DESCRIPTIVE DOCUMENT    ·    VERSION 2026.04</a:t>
             </a:r>
           </a:p>
         </p:txBody>
@@ -3225,8 +3225,8 @@
                 </a:solidFill>
                 <a:latin typeface="Georgia"/>
               </a:rPr>
-              <a:t>Una plataforma operativa
-para vender mobile homes,</a:t>
+              <a:t>An operating platform
+for selling mobile homes,</a:t>
             </a:r>
           </a:p>
         </p:txBody>
@@ -3265,7 +3265,7 @@
                 </a:solidFill>
                 <a:latin typeface="Georgia"/>
               </a:rPr>
-              <a:t>de extremo a extremo.</a:t>
+              <a:t>end to end.</a:t>
             </a:r>
           </a:p>
         </p:txBody>
@@ -3304,8 +3304,8 @@
                 </a:solidFill>
                 <a:latin typeface="Georgia"/>
               </a:rPr>
-              <a:t>Cómo está construida, qué resuelve, y por qué su arquitectura admite
-otros activos físicos con el mismo patrón de negocio.</a:t>
+              <a:t>How it's built, what it solves, and why its architecture supports
+other physical assets that follow the same business pattern.</a:t>
             </a:r>
           </a:p>
         </p:txBody>
@@ -3484,7 +3484,7 @@
                 </a:solidFill>
                 <a:latin typeface="Georgia"/>
               </a:rPr>
-              <a:t>Los seis agentes especializados</a:t>
+              <a:t>The six specialized agents</a:t>
             </a:r>
           </a:p>
         </p:txBody>
@@ -3523,7 +3523,7 @@
                 </a:solidFill>
                 <a:latin typeface="Calibri"/>
               </a:rPr>
-              <a:t>CAPA DE IA</a:t>
+              <a:t>AI LAYER</a:t>
             </a:r>
           </a:p>
         </p:txBody>
@@ -3597,7 +3597,7 @@
                 </a:solidFill>
                 <a:latin typeface="Calibri"/>
               </a:rPr>
-              <a:t>Cada agente vive en api/agents/, hereda de BaseAgent, opera de forma asíncrona y devuelve JSON estructurado validado por Pydantic. No tienen memoria entre llamadas: el contexto necesario se pasa explícitamente en cada request.</a:t>
+              <a:t>Each agent lives under api/agents/, inherits from BaseAgent, runs asynchronously, and returns structured JSON validated by Pydantic. They have no memory between calls: the context required is passed explicitly with every request.</a:t>
             </a:r>
           </a:p>
         </p:txBody>
@@ -3636,7 +3636,7 @@
                 </a:solidFill>
                 <a:latin typeface="Calibri"/>
               </a:rPr>
-              <a:t>AGENTE</a:t>
+              <a:t>AGENT</a:t>
             </a:r>
           </a:p>
         </p:txBody>
@@ -3675,7 +3675,7 @@
                 </a:solidFill>
                 <a:latin typeface="Calibri"/>
               </a:rPr>
-              <a:t>FUNCIÓN</a:t>
+              <a:t>FUNCTION</a:t>
             </a:r>
           </a:p>
         </p:txBody>
@@ -3714,7 +3714,7 @@
                 </a:solidFill>
                 <a:latin typeface="Calibri"/>
               </a:rPr>
-              <a:t>DETALLE RELEVANTE</a:t>
+              <a:t>IMPLEMENTATION NOTE</a:t>
             </a:r>
           </a:p>
         </p:txBody>
@@ -3827,7 +3827,7 @@
                 </a:solidFill>
                 <a:latin typeface="Calibri"/>
               </a:rPr>
-              <a:t>Encuentra mobile homes en el mercado que cumplen las reglas de Maninos.</a:t>
+              <a:t>Finds mobile homes on the market that satisfy Maninos's rules.</a:t>
             </a:r>
           </a:p>
         </p:txBody>
@@ -3866,7 +3866,7 @@
                 </a:solidFill>
                 <a:latin typeface="Calibri"/>
               </a:rPr>
-              <a:t>Scrapea MHVillage, MobileHome.net, MHBay, Zillow, Facebook Marketplace. Filtra por reglas Feb 2026: 60% del valor de mercado, $5K–$80K, 200mi de Houston o Dallas, sin filtro de año.</a:t>
+              <a:t>Scrapes MHVillage, MobileHome.net, MHBay, Zillow, Facebook Marketplace. Filters using the Feb 2026 rules: 60% of market value, $5K–$80K, 200mi from Houston or Dallas, no year filter.</a:t>
             </a:r>
           </a:p>
         </p:txBody>
@@ -3979,7 +3979,7 @@
                 </a:solidFill>
                 <a:latin typeface="Calibri"/>
               </a:rPr>
-              <a:t>Estima el costo de la renovación.</a:t>
+              <a:t>Estimates the renovation cost.</a:t>
             </a:r>
           </a:p>
         </p:txBody>
@@ -4018,7 +4018,7 @@
                 </a:solidFill>
                 <a:latin typeface="Calibri"/>
               </a:rPr>
-              <a:t>Lee el catálogo de materiales desde la base de datos. Devuelve materiales + mano de obra (30–50% material) + contingencia (5–15%) + costo por sqft + factores de riesgo.</a:t>
+              <a:t>Reads the materials catalog from the database. Returns materials + labor (30–50% of materials) + contingency (5–15%) + cost per sqft + risk factors.</a:t>
             </a:r>
           </a:p>
         </p:txBody>
@@ -4131,7 +4131,7 @@
                 </a:solidFill>
                 <a:latin typeface="Calibri"/>
               </a:rPr>
-              <a:t>Propone precio de venta.</a:t>
+              <a:t>Proposes a sale price.</a:t>
             </a:r>
           </a:p>
         </p:txBody>
@@ -4170,7 +4170,7 @@
                 </a:solidFill>
                 <a:latin typeface="Calibri"/>
               </a:rPr>
-              <a:t>Devuelve cuatro estrategias: mínimo, target, mercado, agresivo. Aplica techo automático del 80% del valor de mercado.</a:t>
+              <a:t>Returns four strategies: minimum, target, market, aggressive. Applies an automatic ceiling of 80% of blended market value.</a:t>
             </a:r>
           </a:p>
         </p:txBody>
@@ -4283,7 +4283,7 @@
                 </a:solidFill>
                 <a:latin typeface="Calibri"/>
               </a:rPr>
-              <a:t>Clasifica fotografías por estado de renovación.</a:t>
+              <a:t>Classifies photos by renovation state.</a:t>
             </a:r>
           </a:p>
         </p:txBody>
@@ -4322,7 +4322,7 @@
                 </a:solidFill>
                 <a:latin typeface="Calibri"/>
               </a:rPr>
-              <a:t>Vision real (no keywords). Distingue before / after / exterior / interior. Ordena la galería pública: after primero, después exterior, interior, before.</a:t>
+              <a:t>True vision (no keyword tricks). Distinguishes before / after / exterior / interior. Sorts the public gallery: after first, then exterior, interior, before.</a:t>
             </a:r>
           </a:p>
         </p:txBody>
@@ -4435,7 +4435,7 @@
                 </a:solidFill>
                 <a:latin typeface="Calibri"/>
               </a:rPr>
-              <a:t>Transcribe audio del staff y extrae intención.</a:t>
+              <a:t>Transcribes audio dictated by staff and extracts intent.</a:t>
             </a:r>
           </a:p>
         </p:txBody>
@@ -4474,7 +4474,7 @@
                 </a:solidFill>
                 <a:latin typeface="Calibri"/>
               </a:rPr>
-              <a:t>Whisper en español. Detecta si es una nota de inspección, una lista de materiales o una observación. Funciona con Spanglish.</a:t>
+              <a:t>Whisper in Spanish. Detects whether it's an inspection note, a materials list, or a general observation. Works with Spanglish.</a:t>
             </a:r>
           </a:p>
         </p:txBody>
@@ -4587,7 +4587,7 @@
                 </a:solidFill>
                 <a:latin typeface="Calibri"/>
               </a:rPr>
-              <a:t>Conversación guiada para planificar la renovación.</a:t>
+              <a:t>Guided conversation to plan the renovation.</a:t>
             </a:r>
           </a:p>
         </p:txBody>
@@ -4626,7 +4626,7 @@
                 </a:solidFill>
                 <a:latin typeface="Calibri"/>
               </a:rPr>
-              <a:t>Tiene los precios de los materiales embebidos en el prompt (decisión de latencia). Si no hay sqft, no estima — falla loud.</a:t>
+              <a:t>Material prices are embedded in the prompt itself (a latency choice). If the property has no sqft, it refuses to estimate — fails loud.</a:t>
             </a:r>
           </a:p>
         </p:txBody>
@@ -4735,7 +4735,7 @@
                 </a:solidFill>
                 <a:latin typeface="Calibri"/>
               </a:rPr>
-              <a:t>Aparte: el chat flotante AIChatWidget que aparece en el portal Homes no usa estos agentes. Llama a /api/ai/chat (gpt-5-mini) con un patrón de tool-calling sobre 19 herramientas de consulta a la base de datos.</a:t>
+              <a:t>Aside: the floating AIChatWidget chat in the Homes portal does not use these agents. It calls /api/ai/chat (gpt-5-mini) with a tool-calling pattern over 19 database query tools.</a:t>
             </a:r>
           </a:p>
         </p:txBody>
@@ -4774,7 +4774,7 @@
                 </a:solidFill>
                 <a:latin typeface="Calibri"/>
               </a:rPr>
-              <a:t>07  ·  AGENTES</a:t>
+              <a:t>07  ·  AGENTS</a:t>
             </a:r>
           </a:p>
         </p:txBody>
@@ -4813,7 +4813,7 @@
                 </a:solidFill>
                 <a:latin typeface="Calibri"/>
               </a:rPr>
-              <a:t>6 ESPECIALIZADOS  +  1 ASISTENTE CONVERSACIONAL</a:t>
+              <a:t>6 SPECIALIZED  +  1 CONVERSATIONAL ASSISTANT</a:t>
             </a:r>
           </a:p>
         </p:txBody>
@@ -4914,7 +4914,7 @@
                 </a:solidFill>
                 <a:latin typeface="Georgia"/>
               </a:rPr>
-              <a:t>El scheduler</a:t>
+              <a:t>The scheduler</a:t>
             </a:r>
           </a:p>
         </p:txBody>
@@ -4953,7 +4953,7 @@
                 </a:solidFill>
                 <a:latin typeface="Calibri"/>
               </a:rPr>
-              <a:t>AUTOMATIZACIÓN EN BACKGROUND</a:t>
+              <a:t>BACKGROUND AUTOMATION</a:t>
             </a:r>
           </a:p>
         </p:txBody>
@@ -5027,7 +5027,7 @@
                 </a:solidFill>
                 <a:latin typeface="Calibri"/>
               </a:rPr>
-              <a:t>APScheduler corriendo en zona horaria US Central. Diez jobs en producción. Cada ejecución, exitosa o fallida, deja registro en la tabla scheduler_runs — el widget en /homes/transfers lee de ahí, no de la memoria del scheduler.</a:t>
+              <a:t>APScheduler runs on the US Central timezone. Ten jobs in production. Every run, successful or failed, leaves a record in the scheduler_runs table — the widget at /homes/transfers reads from that table, not from the scheduler's in-memory state.</a:t>
             </a:r>
           </a:p>
         </p:txBody>
@@ -5105,7 +5105,7 @@
                 </a:solidFill>
                 <a:latin typeface="Calibri"/>
               </a:rPr>
-              <a:t>CADENCIA</a:t>
+              <a:t>CADENCE</a:t>
             </a:r>
           </a:p>
         </p:txBody>
@@ -5144,7 +5144,7 @@
                 </a:solidFill>
                 <a:latin typeface="Calibri"/>
               </a:rPr>
-              <a:t>FUNCIÓN</a:t>
+              <a:t>FUNCTION</a:t>
             </a:r>
           </a:p>
         </p:txBody>
@@ -5257,7 +5257,7 @@
                 </a:solidFill>
                 <a:latin typeface="Calibri"/>
               </a:rPr>
-              <a:t>Cada 30 min</a:t>
+              <a:t>Every 30 min</a:t>
             </a:r>
           </a:p>
         </p:txBody>
@@ -5296,7 +5296,7 @@
                 </a:solidFill>
                 <a:latin typeface="Calibri"/>
               </a:rPr>
-              <a:t>Envía emails programados pendientes.</a:t>
+              <a:t>Sends pending scheduled emails.</a:t>
             </a:r>
           </a:p>
         </p:txBody>
@@ -5409,7 +5409,7 @@
                 </a:solidFill>
                 <a:latin typeface="Calibri"/>
               </a:rPr>
-              <a:t>Diario · 8:00 CT</a:t>
+              <a:t>Daily · 8:00 CT</a:t>
             </a:r>
           </a:p>
         </p:txBody>
@@ -5448,7 +5448,7 @@
                 </a:solidFill>
                 <a:latin typeface="Calibri"/>
               </a:rPr>
-              <a:t>Recordatorios de pago RTO al cliente (3d antes, día del pago, 1d después).</a:t>
+              <a:t>RTO payment reminders to the customer (3d before, day-of, 1d after).</a:t>
             </a:r>
           </a:p>
         </p:txBody>
@@ -5561,7 +5561,7 @@
                 </a:solidFill>
                 <a:latin typeface="Calibri"/>
               </a:rPr>
-              <a:t>Diario · 9:00 CT</a:t>
+              <a:t>Daily · 9:00 CT</a:t>
             </a:r>
           </a:p>
         </p:txBody>
@@ -5600,7 +5600,7 @@
                 </a:solidFill>
                 <a:latin typeface="Calibri"/>
               </a:rPr>
-              <a:t>Alertas internas para pagos RTO vencidos.</a:t>
+              <a:t>Internal alerts for overdue RTO payments.</a:t>
             </a:r>
           </a:p>
         </p:txBody>
@@ -5713,7 +5713,7 @@
                 </a:solidFill>
                 <a:latin typeface="Calibri"/>
               </a:rPr>
-              <a:t>Diario · 9:30 CT</a:t>
+              <a:t>Daily · 9:30 CT</a:t>
             </a:r>
           </a:p>
         </p:txBody>
@@ -5752,7 +5752,7 @@
                 </a:solidFill>
                 <a:latin typeface="Calibri"/>
               </a:rPr>
-              <a:t>Avisa al equipo de pagarés a vencer (90 / 60 / 30 días).</a:t>
+              <a:t>Notifies the team of upcoming note maturities (90 / 60 / 30 days).</a:t>
             </a:r>
           </a:p>
         </p:txBody>
@@ -5865,7 +5865,7 @@
                 </a:solidFill>
                 <a:latin typeface="Calibri"/>
               </a:rPr>
-              <a:t>Diario · 10:00 CT</a:t>
+              <a:t>Daily · 10:00 CT</a:t>
             </a:r>
           </a:p>
         </p:txBody>
@@ -5904,7 +5904,7 @@
                 </a:solidFill>
                 <a:latin typeface="Calibri"/>
               </a:rPr>
-              <a:t>Consulta TDHCA por cada serial pendiente, fuzzy-match del nombre.</a:t>
+              <a:t>Queries TDHCA for each pending serial, fuzzy-matches the owner name.</a:t>
             </a:r>
           </a:p>
         </p:txBody>
@@ -6017,7 +6017,7 @@
                 </a:solidFill>
                 <a:latin typeface="Calibri"/>
               </a:rPr>
-              <a:t>Día 1 · 10:30 CT</a:t>
+              <a:t>1st of month · 10:30 CT</a:t>
             </a:r>
           </a:p>
         </p:txBody>
@@ -6056,7 +6056,7 @@
                 </a:solidFill>
                 <a:latin typeface="Calibri"/>
               </a:rPr>
-              <a:t>Estado mensual a cada inversor con su PDF.</a:t>
+              <a:t>Monthly statement to each investor with attached PDF.</a:t>
             </a:r>
           </a:p>
         </p:txBody>
@@ -6169,7 +6169,7 @@
                 </a:solidFill>
                 <a:latin typeface="Calibri"/>
               </a:rPr>
-              <a:t>Cada 2 horas</a:t>
+              <a:t>Every 2 hours</a:t>
             </a:r>
           </a:p>
         </p:txBody>
@@ -6208,7 +6208,7 @@
                 </a:solidFill>
                 <a:latin typeface="Calibri"/>
               </a:rPr>
-              <a:t>Consistencia cruzada Homes ↔ Capital.</a:t>
+              <a:t>Cross-consistency between Homes ↔ Capital.</a:t>
             </a:r>
           </a:p>
         </p:txBody>
@@ -6321,7 +6321,7 @@
                 </a:solidFill>
                 <a:latin typeface="Calibri"/>
               </a:rPr>
-              <a:t>Cada 6 horas</a:t>
+              <a:t>Every 6 hours</a:t>
             </a:r>
           </a:p>
         </p:txBody>
@@ -6360,7 +6360,7 @@
                 </a:solidFill>
                 <a:latin typeface="Calibri"/>
               </a:rPr>
-              <a:t>Refresca listings de VMF Homes y 21st Mortgage.</a:t>
+              <a:t>Refreshes VMF Homes and 21st Mortgage listings.</a:t>
             </a:r>
           </a:p>
         </p:txBody>
@@ -6473,7 +6473,7 @@
                 </a:solidFill>
                 <a:latin typeface="Calibri"/>
               </a:rPr>
-              <a:t>Lun y Jue · 7:00 CT</a:t>
+              <a:t>Mon and Thu · 7:00 CT</a:t>
             </a:r>
           </a:p>
         </p:txBody>
@@ -6512,7 +6512,7 @@
                 </a:solidFill>
                 <a:latin typeface="Calibri"/>
               </a:rPr>
-              <a:t>Scraping de Facebook Marketplace vía Apify.</a:t>
+              <a:t>Facebook Marketplace scraping via Apify.</a:t>
             </a:r>
           </a:p>
         </p:txBody>
@@ -6625,7 +6625,7 @@
                 </a:solidFill>
                 <a:latin typeface="Calibri"/>
               </a:rPr>
-              <a:t>Diario · 6:00 CT</a:t>
+              <a:t>Daily · 6:00 CT</a:t>
             </a:r>
           </a:p>
         </p:txBody>
@@ -6664,7 +6664,7 @@
                 </a:solidFill>
                 <a:latin typeface="Calibri"/>
               </a:rPr>
-              <a:t>Marca como expirados listings con más de 14 días.</a:t>
+              <a:t>Marks listings older than 14 days as expired.</a:t>
             </a:r>
           </a:p>
         </p:txBody>
@@ -6777,7 +6777,7 @@
                 </a:solidFill>
                 <a:latin typeface="Calibri"/>
               </a:rPr>
-              <a:t>10 JOBS  ·  US CENTRAL  ·  AUDIT EN scheduler_runs</a:t>
+              <a:t>10 JOBS  ·  US CENTRAL  ·  AUDIT IN scheduler_runs</a:t>
             </a:r>
           </a:p>
         </p:txBody>
@@ -6878,7 +6878,7 @@
                 </a:solidFill>
                 <a:latin typeface="Georgia"/>
               </a:rPr>
-              <a:t>El flujo del título estatal</a:t>
+              <a:t>The state title flow</a:t>
             </a:r>
           </a:p>
         </p:txBody>
@@ -6917,7 +6917,7 @@
                 </a:solidFill>
                 <a:latin typeface="Calibri"/>
               </a:rPr>
-              <a:t>TDHCA Y HERENCIA</a:t>
+              <a:t>TDHCA AND LEGACY</a:t>
             </a:r>
           </a:p>
         </p:txBody>
@@ -6991,7 +6991,7 @@
                 </a:solidFill>
                 <a:latin typeface="Calibri"/>
               </a:rPr>
-              <a:t>En Texas, la transferencia de propiedad de un mobile home se registra en TDHCA mediante el Statement of Ownership. Maninos OS automatiza el seguimiento.</a:t>
+              <a:t>In Texas, transfer of ownership for a mobile home is recorded with TDHCA via the Statement of Ownership. Maninos OS automates the follow-up.</a:t>
             </a:r>
           </a:p>
         </p:txBody>
@@ -7030,7 +7030,7 @@
                 </a:solidFill>
                 <a:latin typeface="Calibri"/>
               </a:rPr>
-              <a:t>FLUJO AUTOMÁTICO</a:t>
+              <a:t>AUTOMATIC FLOW</a:t>
             </a:r>
           </a:p>
         </p:txBody>
@@ -7069,7 +7069,7 @@
                 </a:solidFill>
                 <a:latin typeface="Calibri"/>
               </a:rPr>
-              <a:t>1.  Al subir el documento de aplicación de título, el agente extrae el HUD label / serial.</a:t>
+              <a:t>1.  When the title application document is uploaded, the agent extracts the HUD label / serial.</a:t>
             </a:r>
           </a:p>
         </p:txBody>
@@ -7108,7 +7108,7 @@
                 </a:solidFill>
                 <a:latin typeface="Calibri"/>
               </a:rPr>
-              <a:t>2.  Si la aplicación de título no tiene el dato, fallback al Bill of Sale (bos_purchase.hud_label_number).</a:t>
+              <a:t>2.  If the title application doesn't carry the value, falls back to the Bill of Sale (bos_purchase.hud_label_number).</a:t>
             </a:r>
           </a:p>
         </p:txBody>
@@ -7147,7 +7147,7 @@
                 </a:solidFill>
                 <a:latin typeface="Calibri"/>
               </a:rPr>
-              <a:t>3.  El job diario de las 10:00 CT consulta el portal TDHCA por cada serial pendiente.</a:t>
+              <a:t>3.  The 10:00 CT daily job queries the TDHCA portal for each pending serial.</a:t>
             </a:r>
           </a:p>
         </p:txBody>
@@ -7186,7 +7186,7 @@
                 </a:solidFill>
                 <a:latin typeface="Calibri"/>
               </a:rPr>
-              <a:t>4.  Compara el nombre que devuelve TDHCA contra to_name con un fuzzy-match.</a:t>
+              <a:t>4.  Fuzzy-matches the name TDHCA returns against to_name.</a:t>
             </a:r>
           </a:p>
         </p:txBody>
@@ -7225,7 +7225,7 @@
                 </a:solidFill>
                 <a:latin typeface="Calibri"/>
               </a:rPr>
-              <a:t>5.  Si coinciden, marca title_name_updated = TRUE, registra el nombre en tdhca_owner_name, mueve la transferencia a completed.</a:t>
+              <a:t>5.  If they match, sets title_name_updated = TRUE, records the name in tdhca_owner_name, moves the transfer to completed.</a:t>
             </a:r>
           </a:p>
         </p:txBody>
@@ -7264,7 +7264,7 @@
                 </a:solidFill>
                 <a:latin typeface="Calibri"/>
               </a:rPr>
-              <a:t>CASAS LEGACY</a:t>
+              <a:t>LEGACY HOUSES</a:t>
             </a:r>
           </a:p>
         </p:txBody>
@@ -7303,7 +7303,7 @@
                 </a:solidFill>
                 <a:latin typeface="Calibri"/>
               </a:rPr>
-              <a:t>Las casas vendidas antes de la plataforma no están en el sistema y su transferencia ya se hizo fuera. Para incorporarlas, el portal Homes ofrece la subida manual:</a:t>
+              <a:t>Houses sold before the platform existed are not in the system, and their transfer was already done outside it. To bring them in, the Homes portal exposes a manual upload flow:</a:t>
             </a:r>
           </a:p>
         </p:txBody>
@@ -7342,7 +7342,7 @@
                 </a:solidFill>
                 <a:latin typeface="Calibri"/>
               </a:rPr>
-              <a:t>—  Permite crear la propiedad y la transferencia desde cero o desde una propiedad existente.</a:t>
+              <a:t>—  Lets you create the property and the transfer from scratch, or against an existing property.</a:t>
             </a:r>
           </a:p>
         </p:txBody>
@@ -7381,7 +7381,7 @@
                 </a:solidFill>
                 <a:latin typeface="Calibri"/>
               </a:rPr>
-              <a:t>—  Si la casa está vendida, pide el comprador y crea la transferencia de venta correspondiente.</a:t>
+              <a:t>—  If the house is already sold, asks for the buyer and creates the matching sale transfer.</a:t>
             </a:r>
           </a:p>
         </p:txBody>
@@ -7420,7 +7420,7 @@
                 </a:solidFill>
                 <a:latin typeface="Calibri"/>
               </a:rPr>
-              <a:t>—  Marca is_manual_upload = TRUE y title_name_updated = TRUE para que el job diario las ignore.</a:t>
+              <a:t>—  Sets is_manual_upload = TRUE and title_name_updated = TRUE so the daily job ignores them.</a:t>
             </a:r>
           </a:p>
         </p:txBody>
@@ -7459,7 +7459,7 @@
                 </a:solidFill>
                 <a:latin typeface="Calibri"/>
               </a:rPr>
-              <a:t>—  El serial mostrado en el listado es un link directo a la ficha pública de TDHCA.</a:t>
+              <a:t>—  The serial shown in the listing is a direct link to the public TDHCA record.</a:t>
             </a:r>
           </a:p>
         </p:txBody>
@@ -7498,7 +7498,7 @@
                 </a:solidFill>
                 <a:latin typeface="Calibri"/>
               </a:rPr>
-              <a:t>09  ·  TÍTULOS</a:t>
+              <a:t>09  ·  TITLES</a:t>
             </a:r>
           </a:p>
         </p:txBody>
@@ -7537,7 +7537,7 @@
                 </a:solidFill>
                 <a:latin typeface="Calibri"/>
               </a:rPr>
-              <a:t>TDHCA + MANUAL  ·  AUDIT CADA NOCHE</a:t>
+              <a:t>TDHCA + MANUAL  ·  AUDIT EACH NIGHT</a:t>
             </a:r>
           </a:p>
         </p:txBody>
@@ -7638,7 +7638,7 @@
                 </a:solidFill>
                 <a:latin typeface="Georgia"/>
               </a:rPr>
-              <a:t>El módulo de financiamiento propio</a:t>
+              <a:t>The in-house financing module</a:t>
             </a:r>
           </a:p>
         </p:txBody>
@@ -7677,7 +7677,7 @@
                 </a:solidFill>
                 <a:latin typeface="Calibri"/>
               </a:rPr>
-              <a:t>RTO EN DETALLE</a:t>
+              <a:t>RTO IN DETAIL</a:t>
             </a:r>
           </a:p>
         </p:txBody>
@@ -7751,7 +7751,7 @@
                 </a:solidFill>
                 <a:latin typeface="Calibri"/>
               </a:rPr>
-              <a:t>El contrato base es el Texas Residential Lease With Purchase Option (33 cláusulas). Los defaults numéricos están escritos en el código y son configurables por contrato.</a:t>
+              <a:t>The base contract is the Texas Residential Lease With Purchase Option (33 clauses). The numeric defaults live in code and are configurable per contract.</a:t>
             </a:r>
           </a:p>
         </p:txBody>
@@ -7869,7 +7869,7 @@
                 </a:solidFill>
                 <a:latin typeface="Calibri"/>
               </a:rPr>
-              <a:t>/día</a:t>
+              <a:t>/day</a:t>
             </a:r>
           </a:p>
         </p:txBody>
@@ -7991,7 +7991,7 @@
                 </a:solidFill>
                 <a:latin typeface="Calibri"/>
               </a:rPr>
-              <a:t> días</a:t>
+              <a:t> days</a:t>
             </a:r>
           </a:p>
         </p:txBody>
@@ -8030,7 +8030,7 @@
                 </a:solidFill>
                 <a:latin typeface="Calibri"/>
               </a:rPr>
-              <a:t>PERÍODO DE GRACIA</a:t>
+              <a:t>GRACE PERIOD</a:t>
             </a:r>
           </a:p>
         </p:txBody>
@@ -8152,7 +8152,7 @@
                 </a:solidFill>
                 <a:latin typeface="Calibri"/>
               </a:rPr>
-              <a:t>DÍA DEL MES DE VENCIMIENTO</a:t>
+              <a:t>DUE DAY OF MONTH</a:t>
             </a:r>
           </a:p>
         </p:txBody>
@@ -8357,7 +8357,7 @@
                 </a:solidFill>
                 <a:latin typeface="Calibri"/>
               </a:rPr>
-              <a:t>/mes</a:t>
+              <a:t>/month</a:t>
             </a:r>
           </a:p>
         </p:txBody>
@@ -8435,7 +8435,7 @@
                 </a:solidFill>
                 <a:latin typeface="Calibri"/>
               </a:rPr>
-              <a:t>Defaults aplicados por la migración 012_maninos_capital.sql. Cada contrato puede sobrescribirlos.</a:t>
+              <a:t>Defaults applied by migration 012_maninos_capital.sql. Each contract can override them.</a:t>
             </a:r>
           </a:p>
         </p:txBody>
@@ -8509,7 +8509,7 @@
                 </a:solidFill>
                 <a:latin typeface="Calibri"/>
               </a:rPr>
-              <a:t>LO QUE EL DEALER VE CADA DÍA</a:t>
+              <a:t>WHAT THE DEALER SEES EVERY DAY</a:t>
             </a:r>
           </a:p>
         </p:txBody>
@@ -8548,7 +8548,7 @@
                 </a:solidFill>
                 <a:latin typeface="Calibri"/>
               </a:rPr>
-              <a:t>—  Solicitudes RTO entrantes con su scoring de underwriting</a:t>
+              <a:t>—  Incoming RTO applications with their underwriting score</a:t>
             </a:r>
           </a:p>
         </p:txBody>
@@ -8587,7 +8587,7 @@
                 </a:solidFill>
                 <a:latin typeface="Calibri"/>
               </a:rPr>
-              <a:t>—  Pagos del mes con su confirmación pendiente o aplicada</a:t>
+              <a:t>—  The month's payments with confirmation pending or applied</a:t>
             </a:r>
           </a:p>
         </p:txBody>
@@ -8626,7 +8626,7 @@
                 </a:solidFill>
                 <a:latin typeface="Calibri"/>
               </a:rPr>
-              <a:t>—  Cartera vencida segmentada por aging (0–30, 31–60, 61–90, 90+)</a:t>
+              <a:t>—  Past-due portfolio segmented by aging (0–30, 31–60, 61–90, 90+)</a:t>
             </a:r>
           </a:p>
         </p:txBody>
@@ -8665,7 +8665,7 @@
                 </a:solidFill>
                 <a:latin typeface="Calibri"/>
               </a:rPr>
-              <a:t>—  Comisiones por venta dividas finder vs closer, pendientes vs pagadas</a:t>
+              <a:t>—  Per-sale commissions split into finder vs closer, pending vs paid</a:t>
             </a:r>
           </a:p>
         </p:txBody>
@@ -8704,7 +8704,7 @@
                 </a:solidFill>
                 <a:latin typeface="Calibri"/>
               </a:rPr>
-              <a:t>—  Alertas de seguros del cliente próximos a vencer</a:t>
+              <a:t>—  Alerts for customer insurance about to lapse</a:t>
             </a:r>
           </a:p>
         </p:txBody>
@@ -8743,7 +8743,7 @@
                 </a:solidFill>
                 <a:latin typeface="Calibri"/>
               </a:rPr>
-              <a:t>LO QUE EL CLIENTE VE EN SU CUENTA</a:t>
+              <a:t>WHAT THE CUSTOMER SEES IN THEIR ACCOUNT</a:t>
             </a:r>
           </a:p>
         </p:txBody>
@@ -8782,7 +8782,7 @@
                 </a:solidFill>
                 <a:latin typeface="Calibri"/>
               </a:rPr>
-              <a:t>—  Su tabla de amortización con meses pasados, presente y futuros</a:t>
+              <a:t>—  Their amortization table with past, current, and future months</a:t>
             </a:r>
           </a:p>
         </p:txBody>
@@ -8821,7 +8821,7 @@
                 </a:solidFill>
                 <a:latin typeface="Calibri"/>
               </a:rPr>
-              <a:t>—  Total pagado y saldo restante</a:t>
+              <a:t>—  Total paid and remaining balance</a:t>
             </a:r>
           </a:p>
         </p:txBody>
@@ -8860,7 +8860,7 @@
                 </a:solidFill>
                 <a:latin typeface="Calibri"/>
               </a:rPr>
-              <a:t>—  Botón para reportar el pago del mes con método y referencia</a:t>
+              <a:t>—  A button to report this month's payment with method and reference</a:t>
             </a:r>
           </a:p>
         </p:txBody>
@@ -8899,7 +8899,7 @@
                 </a:solidFill>
                 <a:latin typeface="Calibri"/>
               </a:rPr>
-              <a:t>—  Estado de su KYC y su contrato</a:t>
+              <a:t>—  The status of their KYC and contract</a:t>
             </a:r>
           </a:p>
         </p:txBody>
@@ -8938,7 +8938,7 @@
                 </a:solidFill>
                 <a:latin typeface="Calibri"/>
               </a:rPr>
-              <a:t>—  Notificaciones de pagos próximos y vencidos</a:t>
+              <a:t>—  Notifications for upcoming and overdue payments</a:t>
             </a:r>
           </a:p>
         </p:txBody>
@@ -9016,7 +9016,7 @@
                 </a:solidFill>
                 <a:latin typeface="Calibri"/>
               </a:rPr>
-              <a:t>33 CLÁUSULAS  ·  DOBLE VISTA (OPERADOR + CLIENTE)</a:t>
+              <a:t>33 CLAUSES  ·  DUAL VIEW (OPERATOR + CUSTOMER)</a:t>
             </a:r>
           </a:p>
         </p:txBody>
@@ -9117,7 +9117,7 @@
                 </a:solidFill>
                 <a:latin typeface="Georgia"/>
               </a:rPr>
-              <a:t>La capa contable</a:t>
+              <a:t>The accounting layer</a:t>
             </a:r>
           </a:p>
         </p:txBody>
@@ -9156,7 +9156,7 @@
                 </a:solidFill>
                 <a:latin typeface="Calibri"/>
               </a:rPr>
-              <a:t>GL COMPLETO, DOS ENTIDADES</a:t>
+              <a:t>FULL GL, TWO ENTITIES</a:t>
             </a:r>
           </a:p>
         </p:txBody>
@@ -9230,7 +9230,7 @@
                 </a:solidFill>
                 <a:latin typeface="Calibri"/>
               </a:rPr>
-              <a:t>Maninos OS no se apoya en QuickBooks externo: implementa su propio General Ledger con una estructura inspirada en el chart of accounts de QuickBooks. Hay dos contabilidades separadas — una para Homes, otra para Capital — porque son dos LLCs distintas con reportes independientes.</a:t>
+              <a:t>Maninos OS doesn't lean on an external QuickBooks: it implements its own General Ledger with a structure inspired by QuickBooks' chart of accounts. There are two separate sets of books — one for Homes, one for Capital — because they are two distinct LLCs with independent reporting.</a:t>
             </a:r>
           </a:p>
         </p:txBody>
@@ -9269,7 +9269,7 @@
                 </a:solidFill>
                 <a:latin typeface="Calibri"/>
               </a:rPr>
-              <a:t>TABLAS IMPLICADAS</a:t>
+              <a:t>TABLES INVOLVED</a:t>
             </a:r>
           </a:p>
         </p:txBody>
@@ -9363,7 +9363,7 @@
                 </a:solidFill>
                 <a:latin typeface="Consolas"/>
               </a:rPr>
-              <a:t>// chart of accounts Homes</a:t>
+              <a:t>// chart of accounts (Homes)</a:t>
             </a:r>
           </a:p>
         </p:txBody>
@@ -9411,7 +9411,7 @@
                 </a:solidFill>
                 <a:latin typeface="Consolas"/>
               </a:rPr>
-              <a:t>// asientos contables</a:t>
+              <a:t>// journal entries</a:t>
             </a:r>
           </a:p>
         </p:txBody>
@@ -9459,7 +9459,7 @@
                 </a:solidFill>
                 <a:latin typeface="Consolas"/>
               </a:rPr>
-              <a:t>// cuentas bancarias</a:t>
+              <a:t>// bank accounts</a:t>
             </a:r>
           </a:p>
         </p:txBody>
@@ -9507,7 +9507,7 @@
                 </a:solidFill>
                 <a:latin typeface="Consolas"/>
               </a:rPr>
-              <a:t>// reglas recurrentes</a:t>
+              <a:t>// recurring rules</a:t>
             </a:r>
           </a:p>
         </p:txBody>
@@ -9555,7 +9555,7 @@
                 </a:solidFill>
                 <a:latin typeface="Consolas"/>
               </a:rPr>
-              <a:t>// presupuestos</a:t>
+              <a:t>// budgets</a:t>
             </a:r>
           </a:p>
         </p:txBody>
@@ -9603,7 +9603,7 @@
                 </a:solidFill>
                 <a:latin typeface="Consolas"/>
               </a:rPr>
-              <a:t>// auditoría</a:t>
+              <a:t>// audit trail</a:t>
             </a:r>
           </a:p>
         </p:txBody>
@@ -9651,7 +9651,7 @@
                 </a:solidFill>
                 <a:latin typeface="Consolas"/>
               </a:rPr>
-              <a:t>// chart of accounts Capital</a:t>
+              <a:t>// chart of accounts (Capital)</a:t>
             </a:r>
           </a:p>
         </p:txBody>
@@ -9699,7 +9699,7 @@
                 </a:solidFill>
                 <a:latin typeface="Consolas"/>
               </a:rPr>
-              <a:t>// asientos Capital</a:t>
+              <a:t>// Capital journal entries</a:t>
             </a:r>
           </a:p>
         </p:txBody>
@@ -9747,7 +9747,7 @@
                 </a:solidFill>
                 <a:latin typeface="Consolas"/>
               </a:rPr>
-              <a:t>// extractos bancarios</a:t>
+              <a:t>// bank statements</a:t>
             </a:r>
           </a:p>
         </p:txBody>
@@ -9795,7 +9795,7 @@
                 </a:solidFill>
                 <a:latin typeface="Consolas"/>
               </a:rPr>
-              <a:t>// líneas de extracto</a:t>
+              <a:t>// statement lines</a:t>
             </a:r>
           </a:p>
         </p:txBody>
@@ -9843,7 +9843,7 @@
                 </a:solidFill>
                 <a:latin typeface="Consolas"/>
               </a:rPr>
-              <a:t>// presupuestos Capital</a:t>
+              <a:t>// Capital budgets</a:t>
             </a:r>
           </a:p>
         </p:txBody>
@@ -9882,7 +9882,7 @@
                 </a:solidFill>
                 <a:latin typeface="Calibri"/>
               </a:rPr>
-              <a:t>CATEGORÍAS QUE CUBRE</a:t>
+              <a:t>WHAT IT COVERS</a:t>
             </a:r>
           </a:p>
         </p:txBody>
@@ -9921,7 +9921,7 @@
                 </a:solidFill>
                 <a:latin typeface="Calibri"/>
               </a:rPr>
-              <a:t>—  Ingresos: ventas contado, ventas RTO, pagos mensuales</a:t>
+              <a:t>—  Revenue: cash sales, RTO sales, monthly RTO payments</a:t>
             </a:r>
           </a:p>
         </p:txBody>
@@ -9960,7 +9960,7 @@
                 </a:solidFill>
                 <a:latin typeface="Calibri"/>
               </a:rPr>
-              <a:t>—  Gastos: compra, renovación, transporte, comisiones, operativos</a:t>
+              <a:t>—  Expenses: house purchases, renovations, transport, commissions, operating</a:t>
             </a:r>
           </a:p>
         </p:txBody>
@@ -9999,7 +9999,7 @@
                 </a:solidFill>
                 <a:latin typeface="Calibri"/>
               </a:rPr>
-              <a:t>—  Activos: inventario por casa (cada propiedad genera su jerarquía)</a:t>
+              <a:t>—  Assets: per-house inventory (each property generates its own hierarchy)</a:t>
             </a:r>
           </a:p>
         </p:txBody>
@@ -10038,7 +10038,7 @@
                 </a:solidFill>
                 <a:latin typeface="Calibri"/>
               </a:rPr>
-              <a:t>—  Reportes: P&amp;L, balance, flujo de caja, presupuesto vs real, P&amp;L por propiedad y por yard</a:t>
+              <a:t>—  Reports: P&amp;L, balance sheet, cash flow, budget vs actual, P&amp;L per property and per yard</a:t>
             </a:r>
           </a:p>
         </p:txBody>
@@ -10077,7 +10077,7 @@
                 </a:solidFill>
                 <a:latin typeface="Calibri"/>
               </a:rPr>
-              <a:t>—  Reconciliación bancaria con import de extractos y matching</a:t>
+              <a:t>—  Bank reconciliation with statement import and matching against entries</a:t>
             </a:r>
           </a:p>
         </p:txBody>
@@ -10116,7 +10116,7 @@
                 </a:solidFill>
                 <a:latin typeface="Calibri"/>
               </a:rPr>
-              <a:t>—  Audit log para cumplimiento y trazabilidad</a:t>
+              <a:t>—  Audit log for compliance and traceability</a:t>
             </a:r>
           </a:p>
         </p:txBody>
@@ -10155,7 +10155,7 @@
                 </a:solidFill>
                 <a:latin typeface="Calibri"/>
               </a:rPr>
-              <a:t>Los pagos RTO disparan automáticamente el asiento contable correspondiente (_accounting_hooks.py). El equipo no rehace contabilidad.</a:t>
+              <a:t>RTO payments automatically trigger their matching journal entry (_accounting_hooks.py). The team doesn't double-key bookkeeping.</a:t>
             </a:r>
           </a:p>
         </p:txBody>
@@ -10194,7 +10194,7 @@
                 </a:solidFill>
                 <a:latin typeface="Calibri"/>
               </a:rPr>
-              <a:t>11  ·  CONTABILIDAD</a:t>
+              <a:t>11  ·  ACCOUNTING</a:t>
             </a:r>
           </a:p>
         </p:txBody>
@@ -10233,7 +10233,7 @@
                 </a:solidFill>
                 <a:latin typeface="Calibri"/>
               </a:rPr>
-              <a:t>DOS LLCs  ·  GL PROPIO  ·  AUDIT LOG</a:t>
+              <a:t>TWO LLCs  ·  OWN GL  ·  AUDIT LOG</a:t>
             </a:r>
           </a:p>
         </p:txBody>
@@ -10334,7 +10334,7 @@
                 </a:solidFill>
                 <a:latin typeface="Georgia"/>
               </a:rPr>
-              <a:t>El stack técnico</a:t>
+              <a:t>The tech stack</a:t>
             </a:r>
           </a:p>
         </p:txBody>
@@ -10373,7 +10373,7 @@
                 </a:solidFill>
                 <a:latin typeface="Calibri"/>
               </a:rPr>
-              <a:t>SIN SORPRESAS, TODO ESTÁNDAR</a:t>
+              <a:t>NO SURPRISES, ALL STANDARD</a:t>
             </a:r>
           </a:p>
         </p:txBody>
@@ -10447,7 +10447,7 @@
                 </a:solidFill>
                 <a:latin typeface="Calibri"/>
               </a:rPr>
-              <a:t>CAPA</a:t>
+              <a:t>LAYER</a:t>
             </a:r>
           </a:p>
         </p:txBody>
@@ -10486,7 +10486,7 @@
                 </a:solidFill>
                 <a:latin typeface="Calibri"/>
               </a:rPr>
-              <a:t>COMPONENTES</a:t>
+              <a:t>COMPONENTS</a:t>
             </a:r>
           </a:p>
         </p:txBody>
@@ -10599,7 +10599,7 @@
                 </a:solidFill>
                 <a:latin typeface="Calibri"/>
               </a:rPr>
-              <a:t>Python 3.12 con FastAPI. 22 archivos de rutas en Homes, 13 en Capital, 5 públicos. 9 servicios (email, pdf, scheduler, scrapers, title monitor, notification, document, esign, property).</a:t>
+              <a:t>Python 3.12 with FastAPI. 22 route files for Homes, 13 for Capital, 5 public. 9 services (email, pdf, scheduler, scrapers, title monitor, notification, document, esign, property).</a:t>
             </a:r>
           </a:p>
         </p:txBody>
@@ -10673,7 +10673,7 @@
                 </a:solidFill>
                 <a:latin typeface="Calibri"/>
               </a:rPr>
-              <a:t>Datos</a:t>
+              <a:t>Data</a:t>
             </a:r>
           </a:p>
         </p:txBody>
@@ -10712,7 +10712,7 @@
                 </a:solidFill>
                 <a:latin typeface="Calibri"/>
               </a:rPr>
-              <a:t>Supabase: Postgres + Auth + Storage. 58 tablas, 91 migraciones SQL. Acceso vía SDK directo, sin ORM. Service-role key en backend, RLS en buckets públicos.</a:t>
+              <a:t>Supabase: Postgres + Auth + Storage. 58 tables, 91 SQL migrations. Direct SDK access, no ORM. Service-role key on the backend, RLS on public buckets.</a:t>
             </a:r>
           </a:p>
         </p:txBody>
@@ -10825,7 +10825,7 @@
                 </a:solidFill>
                 <a:latin typeface="Calibri"/>
               </a:rPr>
-              <a:t>Next.js 14 con App Router. Tailwind con sistema de diseño propio (paleta navy / oro). Mobile-first responsive. Sin librería de estado externa: hooks de React.</a:t>
+              <a:t>Next.js 14 with the App Router. Tailwind on top of an in-house design system (navy / gold palette). Mobile-first responsive. No external state library: just React hooks.</a:t>
             </a:r>
           </a:p>
         </p:txBody>
@@ -10899,7 +10899,7 @@
                 </a:solidFill>
                 <a:latin typeface="Calibri"/>
               </a:rPr>
-              <a:t>IA</a:t>
+              <a:t>AI</a:t>
             </a:r>
           </a:p>
         </p:txBody>
@@ -10938,7 +10938,7 @@
                 </a:solidFill>
                 <a:latin typeface="Calibri"/>
               </a:rPr>
-              <a:t>OpenAI: gpt-5 en agentes, gpt-5-mini en chat con tool-calling, whisper-1 para transcripción (forzado a español).</a:t>
+              <a:t>OpenAI: gpt-5 in agents, gpt-5-mini in chat with tool-calling, whisper-1 for transcription (locked to Spanish).</a:t>
             </a:r>
           </a:p>
         </p:txBody>
@@ -11051,7 +11051,7 @@
                 </a:solidFill>
                 <a:latin typeface="Calibri"/>
               </a:rPr>
-              <a:t>Resend con templates propios y attachments PDF. Procesamiento de cola de emails programados cada 30 min.</a:t>
+              <a:t>Resend with custom templates and PDF attachments. The scheduled-email queue is processed every 30 min.</a:t>
             </a:r>
           </a:p>
         </p:txBody>
@@ -11164,7 +11164,7 @@
                 </a:solidFill>
                 <a:latin typeface="Calibri"/>
               </a:rPr>
-              <a:t>Playwright para automatización de browser. Apify para Facebook Marketplace.</a:t>
+              <a:t>Playwright for browser automation. Apify for Facebook Marketplace.</a:t>
             </a:r>
           </a:p>
         </p:txBody>
@@ -11238,7 +11238,7 @@
                 </a:solidFill>
                 <a:latin typeface="Calibri"/>
               </a:rPr>
-              <a:t>Despliegue</a:t>
+              <a:t>Deployment</a:t>
             </a:r>
           </a:p>
         </p:txBody>
@@ -11277,7 +11277,7 @@
                 </a:solidFill>
                 <a:latin typeface="Calibri"/>
               </a:rPr>
-              <a:t>Backend en Railway (Docker). Frontend en Vercel. Deploy automático en cada push a main.</a:t>
+              <a:t>Backend on Railway (Docker). Frontend on Vercel. Auto-deploy on every push to main.</a:t>
             </a:r>
           </a:p>
         </p:txBody>
@@ -11351,7 +11351,7 @@
                 </a:solidFill>
                 <a:latin typeface="Calibri"/>
               </a:rPr>
-              <a:t>Observabilidad</a:t>
+              <a:t>Observability</a:t>
             </a:r>
           </a:p>
         </p:txBody>
@@ -11390,7 +11390,7 @@
                 </a:solidFill>
                 <a:latin typeface="Calibri"/>
               </a:rPr>
-              <a:t>structlog para logging estructurado. Logfire opcional para telemetría.</a:t>
+              <a:t>structlog for structured logging. Logfire optional for telemetry.</a:t>
             </a:r>
           </a:p>
         </p:txBody>
@@ -11604,7 +11604,7 @@
                 </a:solidFill>
                 <a:latin typeface="Georgia"/>
               </a:rPr>
-              <a:t>Las reglas del negocio</a:t>
+              <a:t>The business rules</a:t>
             </a:r>
           </a:p>
         </p:txBody>
@@ -11717,7 +11717,7 @@
                 </a:solidFill>
                 <a:latin typeface="Calibri"/>
               </a:rPr>
-              <a:t>Las reglas viven en el código y se aplican automáticamente. No son recomendaciones del agente: son guardarraíles que las APIs y los agentes respetan.</a:t>
+              <a:t>The rules live in code and are applied automatically. They aren't agent suggestions: they are guardrails that the APIs and the agents respect.</a:t>
             </a:r>
           </a:p>
         </p:txBody>
@@ -11756,7 +11756,7 @@
                 </a:solidFill>
                 <a:latin typeface="Calibri"/>
               </a:rPr>
-              <a:t>ADQUISICIÓN</a:t>
+              <a:t>ACQUISITION</a:t>
             </a:r>
           </a:p>
         </p:txBody>
@@ -11804,7 +11804,7 @@
                 </a:solidFill>
                 <a:latin typeface="Calibri"/>
               </a:rPr>
-              <a:t>Geografía: </a:t>
+              <a:t>Geography: </a:t>
             </a:r>
             <a:r>
               <a:rPr sz="1100" b="0" i="0">
@@ -11813,7 +11813,7 @@
                 </a:solidFill>
                 <a:latin typeface="Calibri"/>
               </a:rPr>
-              <a:t>radio de 200 millas desde Houston o Dallas, solo Texas</a:t>
+              <a:t>200-mile radius from Houston or Dallas, Texas only</a:t>
             </a:r>
           </a:p>
         </p:txBody>
@@ -11861,7 +11861,7 @@
                 </a:solidFill>
                 <a:latin typeface="Calibri"/>
               </a:rPr>
-              <a:t>Precio de compra: </a:t>
+              <a:t>Purchase price: </a:t>
             </a:r>
             <a:r>
               <a:rPr sz="1100" b="0" i="0">
@@ -11870,7 +11870,7 @@
                 </a:solidFill>
                 <a:latin typeface="Calibri"/>
               </a:rPr>
-              <a:t>hasta el 60% del valor de mercado (renovación no incluida)</a:t>
+              <a:t>up to 60% of market value (renovation excluded)</a:t>
             </a:r>
           </a:p>
         </p:txBody>
@@ -11918,7 +11918,7 @@
                 </a:solidFill>
                 <a:latin typeface="Calibri"/>
               </a:rPr>
-              <a:t>Rango aceptado: </a:t>
+              <a:t>Accepted range: </a:t>
             </a:r>
             <a:r>
               <a:rPr sz="1100" b="0" i="0">
@@ -11927,7 +11927,7 @@
                 </a:solidFill>
                 <a:latin typeface="Calibri"/>
               </a:rPr>
-              <a:t>entre $5,000 y $80,000 por propiedad</a:t>
+              <a:t>$5,000 to $80,000 per property</a:t>
             </a:r>
           </a:p>
         </p:txBody>
@@ -11975,7 +11975,7 @@
                 </a:solidFill>
                 <a:latin typeface="Calibri"/>
               </a:rPr>
-              <a:t>Año: </a:t>
+              <a:t>Year: </a:t>
             </a:r>
             <a:r>
               <a:rPr sz="1100" b="0" i="0">
@@ -11984,7 +11984,7 @@
                 </a:solidFill>
                 <a:latin typeface="Calibri"/>
               </a:rPr>
-              <a:t>sin filtro</a:t>
+              <a:t>no filter</a:t>
             </a:r>
           </a:p>
         </p:txBody>
@@ -12032,7 +12032,7 @@
                 </a:solidFill>
                 <a:latin typeface="Calibri"/>
               </a:rPr>
-              <a:t>Tipos: </a:t>
+              <a:t>Types: </a:t>
             </a:r>
             <a:r>
               <a:rPr sz="1100" b="0" i="0">
@@ -12041,7 +12041,7 @@
                 </a:solidFill>
                 <a:latin typeface="Calibri"/>
               </a:rPr>
-              <a:t>single wide y double wide</a:t>
+              <a:t>single wide and double wide</a:t>
             </a:r>
           </a:p>
         </p:txBody>
@@ -12080,7 +12080,7 @@
                 </a:solidFill>
                 <a:latin typeface="Calibri"/>
               </a:rPr>
-              <a:t>RENOVACIÓN Y VENTA</a:t>
+              <a:t>RENOVATION AND SALE</a:t>
             </a:r>
           </a:p>
         </p:txBody>
@@ -12128,7 +12128,7 @@
                 </a:solidFill>
                 <a:latin typeface="Calibri"/>
               </a:rPr>
-              <a:t>Presupuesto de renovación: </a:t>
+              <a:t>Renovation budget: </a:t>
             </a:r>
             <a:r>
               <a:rPr sz="1100" b="0" i="0">
@@ -12137,7 +12137,7 @@
                 </a:solidFill>
                 <a:latin typeface="Calibri"/>
               </a:rPr>
-              <a:t>entre $5,000 y $15,000</a:t>
+              <a:t>$5,000 to $15,000</a:t>
             </a:r>
           </a:p>
         </p:txBody>
@@ -12185,7 +12185,7 @@
                 </a:solidFill>
                 <a:latin typeface="Calibri"/>
               </a:rPr>
-              <a:t>Precio de venta: </a:t>
+              <a:t>Sale price: </a:t>
             </a:r>
             <a:r>
               <a:rPr sz="1100" b="0" i="0">
@@ -12194,7 +12194,7 @@
                 </a:solidFill>
                 <a:latin typeface="Calibri"/>
               </a:rPr>
-              <a:t>hasta el 80% del valor de mercado mezclado (techo enforced por PrecioAgent)</a:t>
+              <a:t>up to 80% of blended market value (ceiling enforced by PrecioAgent)</a:t>
             </a:r>
           </a:p>
         </p:txBody>
@@ -12242,7 +12242,7 @@
                 </a:solidFill>
                 <a:latin typeface="Calibri"/>
               </a:rPr>
-              <a:t>Comisiones: </a:t>
+              <a:t>Commissions: </a:t>
             </a:r>
             <a:r>
               <a:rPr sz="1100" b="0" i="0">
@@ -12251,7 +12251,7 @@
                 </a:solidFill>
                 <a:latin typeface="Calibri"/>
               </a:rPr>
-              <a:t>$1,500 en venta contado · $1,000 en venta RTO</a:t>
+              <a:t>$1,500 on cash sale · $1,000 on RTO sale</a:t>
             </a:r>
           </a:p>
         </p:txBody>
@@ -12299,7 +12299,7 @@
                 </a:solidFill>
                 <a:latin typeface="Calibri"/>
               </a:rPr>
-              <a:t>Reparto de comisión: </a:t>
+              <a:t>Commission split: </a:t>
             </a:r>
             <a:r>
               <a:rPr sz="1100" b="0" i="0">
@@ -12308,7 +12308,7 @@
                 </a:solidFill>
                 <a:latin typeface="Calibri"/>
               </a:rPr>
-              <a:t>50% para el finder, 50% para el closer</a:t>
+              <a:t>50% finder, 50% closer</a:t>
             </a:r>
           </a:p>
         </p:txBody>
@@ -12356,7 +12356,7 @@
                 </a:solidFill>
                 <a:latin typeface="Calibri"/>
               </a:rPr>
-              <a:t>Modalidades de venta: </a:t>
+              <a:t>Sale modes: </a:t>
             </a:r>
             <a:r>
               <a:rPr sz="1100" b="0" i="0">
@@ -12365,7 +12365,7 @@
                 </a:solidFill>
                 <a:latin typeface="Calibri"/>
               </a:rPr>
-              <a:t>contado o RTO</a:t>
+              <a:t>cash or RTO</a:t>
             </a:r>
           </a:p>
         </p:txBody>
@@ -12404,7 +12404,7 @@
                 </a:solidFill>
                 <a:latin typeface="Calibri"/>
               </a:rPr>
-              <a:t>13  ·  REGLAS</a:t>
+              <a:t>13  ·  RULES</a:t>
             </a:r>
           </a:p>
         </p:txBody>
@@ -12443,7 +12443,7 @@
                 </a:solidFill>
                 <a:latin typeface="Calibri"/>
               </a:rPr>
-              <a:t>APLICADAS EN CÓDIGO  ·  FEBRERO 2026</a:t>
+              <a:t>ENFORCED IN CODE  ·  FEBRUARY 2026</a:t>
             </a:r>
           </a:p>
         </p:txBody>
@@ -12588,7 +12588,7 @@
                 </a:solidFill>
                 <a:latin typeface="Georgia"/>
               </a:rPr>
-              <a:t>— PARTE III —</a:t>
+              <a:t>— PART III —</a:t>
             </a:r>
           </a:p>
         </p:txBody>
@@ -12627,7 +12627,7 @@
                 </a:solidFill>
                 <a:latin typeface="Georgia"/>
               </a:rPr>
-              <a:t>El patrón es portable</a:t>
+              <a:t>The pattern is portable</a:t>
             </a:r>
           </a:p>
         </p:txBody>
@@ -12666,7 +12666,7 @@
                 </a:solidFill>
                 <a:latin typeface="Georgia"/>
               </a:rPr>
-              <a:t>El sistema fue construido para mobile homes en Texas, pero su modelo de datos y sus flujos describen una clase más amplia de negocios.</a:t>
+              <a:t>The system was built for mobile homes in Texas, but its data model and its workflows describe a broader class of businesses.</a:t>
             </a:r>
           </a:p>
         </p:txBody>
@@ -12767,7 +12767,7 @@
                 </a:solidFill>
                 <a:latin typeface="Georgia"/>
               </a:rPr>
-              <a:t>Lo que es genérico, lo que es Texas-MH</a:t>
+              <a:t>What is generic, what is Texas-MH</a:t>
             </a:r>
           </a:p>
         </p:txBody>
@@ -12806,7 +12806,7 @@
                 </a:solidFill>
                 <a:latin typeface="Calibri"/>
               </a:rPr>
-              <a:t>ANÁLISIS DE PORTABILIDAD</a:t>
+              <a:t>PORTABILITY ANALYSIS</a:t>
             </a:r>
           </a:p>
         </p:txBody>
@@ -12880,7 +12880,7 @@
                 </a:solidFill>
                 <a:latin typeface="Calibri"/>
               </a:rPr>
-              <a:t>El núcleo del sistema describe un patrón universal: un dealer adquiere un activo físico de alto valor con título registrable, lo reacondiciona, lo vende a crédito propio, y cobra en el tiempo. Cualquier negocio que cumpla ese patrón puede correr sobre Maninos OS con configuración localizada.</a:t>
+              <a:t>The core of the system describes a universal pattern: a dealer acquires a high-value physical asset that carries a registrable title, refurbishes it, sells it on its own credit, and collects over time. Any business that fits that pattern can run on Maninos OS with localized configuration.</a:t>
             </a:r>
           </a:p>
         </p:txBody>
@@ -12919,7 +12919,7 @@
                 </a:solidFill>
                 <a:latin typeface="Calibri"/>
               </a:rPr>
-              <a:t>GENÉRICO — EL MOTOR</a:t>
+              <a:t>GENERIC — THE ENGINE</a:t>
             </a:r>
           </a:p>
         </p:txBody>
@@ -12958,7 +12958,7 @@
                 </a:solidFill>
                 <a:latin typeface="Calibri"/>
               </a:rPr>
-              <a:t>—  Pipeline de adquisición: detectar, calificar, comprar</a:t>
+              <a:t>—  Acquisition pipeline: detect, qualify, buy</a:t>
             </a:r>
           </a:p>
         </p:txBody>
@@ -12997,7 +12997,7 @@
                 </a:solidFill>
                 <a:latin typeface="Calibri"/>
               </a:rPr>
-              <a:t>—  Workflow de reacondicionamiento con materiales, mano de obra y costos</a:t>
+              <a:t>—  Refurbishment workflow with materials, labor, and costs</a:t>
             </a:r>
           </a:p>
         </p:txBody>
@@ -13036,7 +13036,7 @@
                 </a:solidFill>
                 <a:latin typeface="Calibri"/>
               </a:rPr>
-              <a:t>—  Galería de fotos clasificada (vision agnóstico al activo)</a:t>
+              <a:t>—  Classified photo gallery (vision is asset-agnostic)</a:t>
             </a:r>
           </a:p>
         </p:txBody>
@@ -13075,7 +13075,7 @@
                 </a:solidFill>
                 <a:latin typeface="Calibri"/>
               </a:rPr>
-              <a:t>—  Motor RTO/BHPH: contrato, amortización, late fee, NSF, holdover, mora</a:t>
+              <a:t>—  RTO/BHPH engine: contract, amortization, late fee, NSF, holdover, delinquency</a:t>
             </a:r>
           </a:p>
         </p:txBody>
@@ -13114,7 +13114,7 @@
                 </a:solidFill>
                 <a:latin typeface="Calibri"/>
               </a:rPr>
-              <a:t>—  Portal del cliente: KYC, firma electrónica, reporte de pagos, estado de cuenta</a:t>
+              <a:t>—  Customer portal: KYC, e-signature, payment reporting, account statement</a:t>
             </a:r>
           </a:p>
         </p:txBody>
@@ -13153,7 +13153,7 @@
                 </a:solidFill>
                 <a:latin typeface="Calibri"/>
               </a:rPr>
-              <a:t>—  Capital de inversores con promissory notes y reportes mensuales</a:t>
+              <a:t>—  Investor capital with promissory notes and monthly reports</a:t>
             </a:r>
           </a:p>
         </p:txBody>
@@ -13192,7 +13192,7 @@
                 </a:solidFill>
                 <a:latin typeface="Calibri"/>
               </a:rPr>
-              <a:t>—  General Ledger con reconciliación bancaria</a:t>
+              <a:t>—  General Ledger with bank reconciliation</a:t>
             </a:r>
           </a:p>
         </p:txBody>
@@ -13231,7 +13231,7 @@
                 </a:solidFill>
                 <a:latin typeface="Calibri"/>
               </a:rPr>
-              <a:t>—  Asistente conversacional sobre la base de datos</a:t>
+              <a:t>—  Conversational assistant over the database</a:t>
             </a:r>
           </a:p>
         </p:txBody>
@@ -13270,7 +13270,7 @@
                 </a:solidFill>
                 <a:latin typeface="Calibri"/>
               </a:rPr>
-              <a:t>LOCALIZABLE — LA «ASSET PACK»</a:t>
+              <a:t>LOCALIZABLE — THE “ASSET PACK”</a:t>
             </a:r>
           </a:p>
         </p:txBody>
@@ -13318,7 +13318,7 @@
                 </a:solidFill>
                 <a:latin typeface="Calibri"/>
               </a:rPr>
-              <a:t>Schema del activo: </a:t>
+              <a:t>Asset schema: </a:t>
             </a:r>
             <a:r>
               <a:rPr sz="1000" b="0" i="0">
@@ -13327,7 +13327,7 @@
                 </a:solidFill>
                 <a:latin typeface="Calibri"/>
               </a:rPr>
-              <a:t>sqft + HUD label en MH; HIN + nº motor en boats; VIN + odómetro en autos.</a:t>
+              <a:t>sqft + HUD label for MH; HIN + engine number for boats; VIN + odometer for cars.</a:t>
             </a:r>
           </a:p>
         </p:txBody>
@@ -13375,7 +13375,7 @@
                 </a:solidFill>
                 <a:latin typeface="Calibri"/>
               </a:rPr>
-              <a:t>Reglas de adquisición: </a:t>
+              <a:t>Acquisition rules: </a:t>
             </a:r>
             <a:r>
               <a:rPr sz="1000" b="0" i="0">
@@ -13384,7 +13384,7 @@
                 </a:solidFill>
                 <a:latin typeface="Calibri"/>
               </a:rPr>
-              <a:t>el 60% / $5K-$80K / 200mi es de Maninos; otro dealer las suyas.</a:t>
+              <a:t>the 60% / $5K-$80K / 200mi belongs to Maninos; another dealer would have its own.</a:t>
             </a:r>
           </a:p>
         </p:txBody>
@@ -13432,7 +13432,7 @@
                 </a:solidFill>
                 <a:latin typeface="Calibri"/>
               </a:rPr>
-              <a:t>Workflow de título: </a:t>
+              <a:t>Title workflow: </a:t>
             </a:r>
             <a:r>
               <a:rPr sz="1000" b="0" i="0">
@@ -13441,7 +13441,7 @@
                 </a:solidFill>
                 <a:latin typeface="Calibri"/>
               </a:rPr>
-              <a:t>TDHCA en Texas, otra agencia en cada estado, USCG opcional para boats grandes.</a:t>
+              <a:t>TDHCA in Texas, a different agency in each state, USCG optional for large boats.</a:t>
             </a:r>
           </a:p>
         </p:txBody>
@@ -13489,7 +13489,7 @@
                 </a:solidFill>
                 <a:latin typeface="Calibri"/>
               </a:rPr>
-              <a:t>Plantilla de contrato: </a:t>
+              <a:t>Contract template: </a:t>
             </a:r>
             <a:r>
               <a:rPr sz="1000" b="0" i="0">
@@ -13498,7 +13498,7 @@
                 </a:solidFill>
                 <a:latin typeface="Calibri"/>
               </a:rPr>
-              <a:t>Lease with Purchase Option en MH; contrato BHPH en autos.</a:t>
+              <a:t>Lease with Purchase Option for MH; BHPH contract for cars.</a:t>
             </a:r>
           </a:p>
         </p:txBody>
@@ -13546,7 +13546,7 @@
                 </a:solidFill>
                 <a:latin typeface="Calibri"/>
               </a:rPr>
-              <a:t>Fuentes de scraping: </a:t>
+              <a:t>Scraping sources: </a:t>
             </a:r>
             <a:r>
               <a:rPr sz="1000" b="0" i="0">
@@ -13555,7 +13555,7 @@
                 </a:solidFill>
                 <a:latin typeface="Calibri"/>
               </a:rPr>
-              <a:t>MHVillage para MH, Manheim para autos, BoatTrader para boats.</a:t>
+              <a:t>MHVillage for MH, Manheim for cars, BoatTrader for boats.</a:t>
             </a:r>
           </a:p>
         </p:txBody>
@@ -13603,7 +13603,7 @@
                 </a:solidFill>
                 <a:latin typeface="Calibri"/>
               </a:rPr>
-              <a:t>Prompts de los agentes: </a:t>
+              <a:t>Agent prompts: </a:t>
             </a:r>
             <a:r>
               <a:rPr sz="1000" b="0" i="0">
@@ -13612,7 +13612,7 @@
                 </a:solidFill>
                 <a:latin typeface="Calibri"/>
               </a:rPr>
-              <a:t>agente de costos entiende pintura y tablaroca; gelcoat y bottom paint en boats.</a:t>
+              <a:t>the cost agent knows about paint and drywall for houses; gelcoat and bottom paint for boats.</a:t>
             </a:r>
           </a:p>
         </p:txBody>
@@ -13651,7 +13651,7 @@
                 </a:solidFill>
                 <a:latin typeface="Calibri"/>
               </a:rPr>
-              <a:t>14  ·  PORTABILIDAD</a:t>
+              <a:t>14  ·  PORTABILITY</a:t>
             </a:r>
           </a:p>
         </p:txBody>
@@ -13690,7 +13690,7 @@
                 </a:solidFill>
                 <a:latin typeface="Calibri"/>
               </a:rPr>
-              <a:t>NÚCLEO + ASSET PACK</a:t>
+              <a:t>CORE + ASSET PACK</a:t>
             </a:r>
           </a:p>
         </p:txBody>
@@ -13791,7 +13791,7 @@
                 </a:solidFill>
                 <a:latin typeface="Georgia"/>
               </a:rPr>
-              <a:t>Verticales donde el patrón calza</a:t>
+              <a:t>Verticals where the pattern fits</a:t>
             </a:r>
           </a:p>
         </p:txBody>
@@ -13830,7 +13830,7 @@
                 </a:solidFill>
                 <a:latin typeface="Calibri"/>
               </a:rPr>
-              <a:t>LECTURA CUALITATIVA</a:t>
+              <a:t>QUALITATIVE READ</a:t>
             </a:r>
           </a:p>
         </p:txBody>
@@ -13904,7 +13904,7 @@
                 </a:solidFill>
                 <a:latin typeface="Calibri"/>
               </a:rPr>
-              <a:t>No se incluyen tamaños de mercado en este documento porque son estimaciones de terceros que no he verificado. Lo que sigue es una lectura cualitativa basada en cuán literal es la analogía con el caso Maninos.</a:t>
+              <a:t>Market sizes are intentionally absent from this document, because the third-party numbers I'd quote haven't been verified. What follows is a qualitative read based on how literally each vertical maps onto the Maninos case.</a:t>
             </a:r>
           </a:p>
         </p:txBody>
@@ -13982,7 +13982,7 @@
                 </a:solidFill>
                 <a:latin typeface="Calibri"/>
               </a:rPr>
-              <a:t>CÓMO ENCAJA CON EL MOTOR ACTUAL</a:t>
+              <a:t>HOW IT FITS THE CURRENT ENGINE</a:t>
             </a:r>
           </a:p>
         </p:txBody>
@@ -14021,7 +14021,7 @@
                 </a:solidFill>
                 <a:latin typeface="Calibri"/>
               </a:rPr>
-              <a:t>QUÉ HAY QUE ADAPTAR</a:t>
+              <a:t>WHAT NEEDS TO BE ADAPTED</a:t>
             </a:r>
           </a:p>
         </p:txBody>
@@ -14134,7 +14134,7 @@
                 </a:solidFill>
                 <a:latin typeface="Calibri"/>
               </a:rPr>
-              <a:t>El loop comprar → reacondicionar → financiar → cobrar es idéntico. La cartera vencida y el tracking de pagos mensuales son la analogía más directa.</a:t>
+              <a:t>The buy → recondition → finance → collect loop is identical. Past-due portfolio and monthly payment tracking are the most direct analogue.</a:t>
             </a:r>
           </a:p>
         </p:txBody>
@@ -14173,7 +14173,7 @@
                 </a:solidFill>
                 <a:latin typeface="Calibri"/>
               </a:rPr>
-              <a:t>Workflow de título por estado vía DMV. Integraciones starter-interrupt / GPS. Auctions como fuente.</a:t>
+              <a:t>State-by-state title workflow via DMV. Starter-interrupt / GPS integrations. Auctions as sourcing channel.</a:t>
             </a:r>
           </a:p>
         </p:txBody>
@@ -14286,7 +14286,7 @@
                 </a:solidFill>
                 <a:latin typeface="Calibri"/>
               </a:rPr>
-              <a:t>El concepto de “Revisar Casa” se mapea casi sin cambios al PDI (Pre-Delivery Inspection). El ciclo es el mismo.</a:t>
+              <a:t>The “Revisar Casa” concept maps almost unchanged onto the PDI (Pre-Delivery Inspection). Buy-recondition-sell cycle is the same.</a:t>
             </a:r>
           </a:p>
         </p:txBody>
@@ -14325,7 +14325,7 @@
                 </a:solidFill>
                 <a:latin typeface="Calibri"/>
               </a:rPr>
-              <a:t>Schema del activo (motorhome vs towable). Plantilla de inspección PDI.</a:t>
+              <a:t>Asset schema (motorhome vs towable). PDI inspection template.</a:t>
             </a:r>
           </a:p>
         </p:txBody>
@@ -14438,7 +14438,7 @@
                 </a:solidFill>
                 <a:latin typeface="Calibri"/>
               </a:rPr>
-              <a:t>Reacondicionamiento estándar (gelcoat, motor, tapizado). Título estatal análogo. Financiamiento propio es el vacío más grande.</a:t>
+              <a:t>Pre-sale reconditioning is standard (gelcoat, engine, upholstery). Title is state-issued and analogous. In-house financing is the area least served.</a:t>
             </a:r>
           </a:p>
         </p:txBody>
@@ -14477,7 +14477,7 @@
                 </a:solidFill>
                 <a:latin typeface="Calibri"/>
               </a:rPr>
-              <a:t>HIN + datos de motor / trailer en el schema. Estacionalidad. USCG para vessels &gt; 5 net tons.</a:t>
+              <a:t>HIN + engine / trailer data in the schema. Seasonality. USCG documentation for vessels &gt; 5 net tons.</a:t>
             </a:r>
           </a:p>
         </p:txBody>
@@ -14590,7 +14590,7 @@
                 </a:solidFill>
                 <a:latin typeface="Calibri"/>
               </a:rPr>
-              <a:t>Casi 1:1 con MH. Mismo título en muchos estados.</a:t>
+              <a:t>Almost 1:1 with MH. Same title flow in many states.</a:t>
             </a:r>
           </a:p>
         </p:txBody>
@@ -14629,7 +14629,7 @@
                 </a:solidFill>
                 <a:latin typeface="Calibri"/>
               </a:rPr>
-              <a:t>Volumen pequeño; tiene más sentido como módulo dentro de un dealer MH que como vertical independiente.</a:t>
+              <a:t>Volume is small; better as a module inside an MH dealer than a standalone vertical.</a:t>
             </a:r>
           </a:p>
         </p:txBody>
@@ -14703,7 +14703,7 @@
                 </a:solidFill>
                 <a:latin typeface="Calibri"/>
               </a:rPr>
-              <a:t>Maquinaria pesada / tractores</a:t>
+              <a:t>Heavy equipment / tractors</a:t>
             </a:r>
           </a:p>
         </p:txBody>
@@ -14742,7 +14742,7 @@
                 </a:solidFill>
                 <a:latin typeface="Calibri"/>
               </a:rPr>
-              <a:t>Adquisición y reacondicionamiento encajan. El financiamiento propio es raro porque la captiva del fabricante domina.</a:t>
+              <a:t>Acquisition and reconditioning fit. In-house financing is rare because manufacturer captives dominate.</a:t>
             </a:r>
           </a:p>
         </p:txBody>
@@ -14781,7 +14781,7 @@
                 </a:solidFill>
                 <a:latin typeface="Calibri"/>
               </a:rPr>
-              <a:t>UCC-1 en lugar de título. Lock-in de OEM hace el GTM más difícil.</a:t>
+              <a:t>UCC-1 instead of title. OEM lock-in makes go-to-market harder.</a:t>
             </a:r>
           </a:p>
         </p:txBody>
@@ -14855,7 +14855,7 @@
                 </a:solidFill>
                 <a:latin typeface="Calibri"/>
               </a:rPr>
-              <a:t>15  ·  VERTICALES</a:t>
+              <a:t>15  ·  VERTICALS</a:t>
             </a:r>
           </a:p>
         </p:txBody>
@@ -14894,7 +14894,7 @@
                 </a:solidFill>
                 <a:latin typeface="Calibri"/>
               </a:rPr>
-              <a:t>LECTURA CUALITATIVA  ·  SIN CIFRAS DE TERCEROS</a:t>
+              <a:t>QUALITATIVE READ  ·  NO THIRD-PARTY FIGURES</a:t>
             </a:r>
           </a:p>
         </p:txBody>
@@ -14995,7 +14995,7 @@
                 </a:solidFill>
                 <a:latin typeface="Calibri"/>
               </a:rPr>
-              <a:t>DEFINICIÓN</a:t>
+              <a:t>DEFINITION</a:t>
             </a:r>
           </a:p>
         </p:txBody>
@@ -15034,7 +15034,7 @@
                 </a:solidFill>
                 <a:latin typeface="Georgia"/>
               </a:rPr>
-              <a:t>Qué es Maninos OS</a:t>
+              <a:t>What Maninos OS is</a:t>
             </a:r>
           </a:p>
         </p:txBody>
@@ -15073,7 +15073,7 @@
                 </a:solidFill>
                 <a:latin typeface="Georgia"/>
               </a:rPr>
-              <a:t>Es la plataforma de software propietaria que opera Maninos Homes LLC y Maninos Capital LLC. Cubre el ciclo completo de un activo: localización en el mercado, compra, renovación, listado, venta, financiamiento propio (RTO o contado), gestión de pagos recurrentes, transferencia de título y reporte a inversores.</a:t>
+              <a:t>It is the proprietary software platform operated by Maninos Homes LLC and Maninos Capital LLC. It covers the full lifecycle of an asset: market discovery, purchase, renovation, listing, sale, in-house financing (RTO or cash), recurring payment management, title transfer, and investor reporting.</a:t>
             </a:r>
           </a:p>
         </p:txBody>
@@ -15147,7 +15147,7 @@
                 </a:solidFill>
                 <a:latin typeface="Calibri"/>
               </a:rPr>
-              <a:t>LO QUE REEMPLAZA</a:t>
+              <a:t>WHAT IT REPLACES</a:t>
             </a:r>
           </a:p>
         </p:txBody>
@@ -15186,7 +15186,7 @@
                 </a:solidFill>
                 <a:latin typeface="Calibri"/>
               </a:rPr>
-              <a:t>—  Hojas de cálculo y grupos de WhatsApp para inventario y renovación</a:t>
+              <a:t>—  Spreadsheets and WhatsApp threads for inventory and renovation</a:t>
             </a:r>
           </a:p>
         </p:txBody>
@@ -15225,7 +15225,7 @@
                 </a:solidFill>
                 <a:latin typeface="Calibri"/>
               </a:rPr>
-              <a:t>—  Un CRM genérico para clientes y leads</a:t>
+              <a:t>—  A generic CRM for clients and leads</a:t>
             </a:r>
           </a:p>
         </p:txBody>
@@ -15264,7 +15264,7 @@
                 </a:solidFill>
                 <a:latin typeface="Calibri"/>
               </a:rPr>
-              <a:t>—  Un sistema de contabilidad externo</a:t>
+              <a:t>—  An external accounting system</a:t>
             </a:r>
           </a:p>
         </p:txBody>
@@ -15303,7 +15303,7 @@
                 </a:solidFill>
                 <a:latin typeface="Calibri"/>
               </a:rPr>
-              <a:t>—  Un proceso manual de transferencia de título estatal</a:t>
+              <a:t>—  A manual state title transfer process</a:t>
             </a:r>
           </a:p>
         </p:txBody>
@@ -15342,7 +15342,7 @@
                 </a:solidFill>
                 <a:latin typeface="Calibri"/>
               </a:rPr>
-              <a:t>—  Una hoja paralela para tracking de inversores y mora</a:t>
+              <a:t>—  A side spreadsheet for investor and delinquency tracking</a:t>
             </a:r>
           </a:p>
         </p:txBody>
@@ -15381,7 +15381,7 @@
                 </a:solidFill>
                 <a:latin typeface="Calibri"/>
               </a:rPr>
-              <a:t>LO QUE AÑADE QUE NO EXISTE EN OTRA PARTE</a:t>
+              <a:t>WHAT IT ADDS THAT DOESN'T EXIST ELSEWHERE</a:t>
             </a:r>
           </a:p>
         </p:txBody>
@@ -15420,7 +15420,7 @@
                 </a:solidFill>
                 <a:latin typeface="Calibri"/>
               </a:rPr>
-              <a:t>—  Seis agentes de IA especializados, integrados en los flujos de trabajo</a:t>
+              <a:t>—  Six specialized AI agents embedded in the daily workflow</a:t>
             </a:r>
           </a:p>
         </p:txBody>
@@ -15459,7 +15459,7 @@
                 </a:solidFill>
                 <a:latin typeface="Calibri"/>
               </a:rPr>
-              <a:t>—  Un módulo de financiamiento propio (RTO) con su propia contabilidad</a:t>
+              <a:t>—  An in-house financing module (RTO) with its own accounting</a:t>
             </a:r>
           </a:p>
         </p:txBody>
@@ -15498,7 +15498,7 @@
                 </a:solidFill>
                 <a:latin typeface="Calibri"/>
               </a:rPr>
-              <a:t>—  Un portal público para el cliente final con simulador, KYC, firma y autoservicio de pagos</a:t>
+              <a:t>—  A public customer portal with simulator, KYC, e-signature, and self-service payment reporting</a:t>
             </a:r>
           </a:p>
         </p:txBody>
@@ -15537,7 +15537,7 @@
                 </a:solidFill>
                 <a:latin typeface="Calibri"/>
               </a:rPr>
-              <a:t>—  Un módulo separado para gestión de capital de inversores privados</a:t>
+              <a:t>—  A separate module for managing private investor capital</a:t>
             </a:r>
           </a:p>
         </p:txBody>
@@ -15576,7 +15576,7 @@
                 </a:solidFill>
                 <a:latin typeface="Calibri"/>
               </a:rPr>
-              <a:t>01  ·  DEFINICIÓN</a:t>
+              <a:t>01  ·  DEFINITION</a:t>
             </a:r>
           </a:p>
         </p:txBody>
@@ -15716,7 +15716,7 @@
                 </a:solidFill>
                 <a:latin typeface="Georgia"/>
               </a:rPr>
-              <a:t>Dónde está hoy Maninos OS</a:t>
+              <a:t>Where Maninos OS stands today</a:t>
             </a:r>
           </a:p>
         </p:txBody>
@@ -15755,7 +15755,7 @@
                 </a:solidFill>
                 <a:latin typeface="Calibri"/>
               </a:rPr>
-              <a:t>ESTADO VERIFICABLE</a:t>
+              <a:t>VERIFIABLE STATUS</a:t>
             </a:r>
           </a:p>
         </p:txBody>
@@ -15829,7 +15829,7 @@
                 </a:solidFill>
                 <a:latin typeface="Calibri"/>
               </a:rPr>
-              <a:t>Lo siguiente es lo que hay en el repositorio y en producción ahora mismo, contado contra el código actual.</a:t>
+              <a:t>What follows is what's in the repository and in production right now, counted against the current code.</a:t>
             </a:r>
           </a:p>
         </p:txBody>
@@ -15977,7 +15977,7 @@
                 </a:solidFill>
                 <a:latin typeface="Calibri"/>
               </a:rPr>
-              <a:t>PORTALES EN PRODUCCIÓN</a:t>
+              <a:t>PORTALS IN PRODUCTION</a:t>
             </a:r>
           </a:p>
         </p:txBody>
@@ -16090,7 +16090,7 @@
                 </a:solidFill>
                 <a:latin typeface="Calibri"/>
               </a:rPr>
-              <a:t>PÁGINAS FRONTEND (18+19+16)</a:t>
+              <a:t>FRONTEND PAGES (18+19+16)</a:t>
             </a:r>
           </a:p>
         </p:txBody>
@@ -16203,7 +16203,7 @@
                 </a:solidFill>
                 <a:latin typeface="Calibri"/>
               </a:rPr>
-              <a:t>ARCHIVOS DE RUTAS BACKEND</a:t>
+              <a:t>BACKEND ROUTE FILES</a:t>
             </a:r>
           </a:p>
         </p:txBody>
@@ -16316,7 +16316,7 @@
                 </a:solidFill>
                 <a:latin typeface="Calibri"/>
               </a:rPr>
-              <a:t>AGENTES ESPECIALIZADOS</a:t>
+              <a:t>SPECIALIZED AGENTS</a:t>
             </a:r>
           </a:p>
         </p:txBody>
@@ -16429,7 +16429,7 @@
                 </a:solidFill>
                 <a:latin typeface="Calibri"/>
               </a:rPr>
-              <a:t>JOBS EN SCHEDULER</a:t>
+              <a:t>SCHEDULER JOBS</a:t>
             </a:r>
           </a:p>
         </p:txBody>
@@ -16503,7 +16503,7 @@
                 </a:solidFill>
                 <a:latin typeface="Calibri"/>
               </a:rPr>
-              <a:t>EN PRODUCCIÓN</a:t>
+              <a:t>IN PRODUCTION</a:t>
             </a:r>
           </a:p>
         </p:txBody>
@@ -16542,7 +16542,7 @@
                 </a:solidFill>
                 <a:latin typeface="Calibri"/>
               </a:rPr>
-              <a:t>—  Operación real diaria del staff de Maninos en el portal Homes</a:t>
+              <a:t>—  Daily real-world operations of the Maninos staff in the Homes portal</a:t>
             </a:r>
           </a:p>
         </p:txBody>
@@ -16581,7 +16581,7 @@
                 </a:solidFill>
                 <a:latin typeface="Calibri"/>
               </a:rPr>
-              <a:t>—  Inversores activos consultando sus reportes en Capital</a:t>
+              <a:t>—  Active investors reading their reports in Capital</a:t>
             </a:r>
           </a:p>
         </p:txBody>
@@ -16620,7 +16620,7 @@
                 </a:solidFill>
                 <a:latin typeface="Calibri"/>
               </a:rPr>
-              <a:t>—  Clientes reportando pagos mensuales desde su cuenta en Clientes</a:t>
+              <a:t>—  Customers reporting monthly payments from their accounts in Customers</a:t>
             </a:r>
           </a:p>
         </p:txBody>
@@ -16659,7 +16659,7 @@
                 </a:solidFill>
                 <a:latin typeface="Calibri"/>
               </a:rPr>
-              <a:t>—  Scheduler diario contra TDHCA dejando audit en scheduler_runs</a:t>
+              <a:t>—  Daily scheduler against TDHCA leaving an audit trail in scheduler_runs</a:t>
             </a:r>
           </a:p>
         </p:txBody>
@@ -16698,7 +16698,7 @@
                 </a:solidFill>
                 <a:latin typeface="Calibri"/>
               </a:rPr>
-              <a:t>—  Agentes de IA en flujos de “Revisar Casa” y planificación de renovación</a:t>
+              <a:t>—  AI agents inside the “Revisar Casa” and renovation-planning flows</a:t>
             </a:r>
           </a:p>
         </p:txBody>
@@ -16737,7 +16737,7 @@
                 </a:solidFill>
                 <a:latin typeface="Calibri"/>
               </a:rPr>
-              <a:t>ÁREAS QUE AÚN TIENEN DEUDA</a:t>
+              <a:t>AREAS THAT STILL CARRY DEBT</a:t>
             </a:r>
           </a:p>
         </p:txBody>
@@ -16776,7 +16776,7 @@
                 </a:solidFill>
                 <a:latin typeface="Calibri"/>
               </a:rPr>
-              <a:t>—  Multi-tenant: hoy es instancia única para Maninos. Falta separación de tenants.</a:t>
+              <a:t>—  Multi-tenant: today the system runs as a single instance for Maninos. Tenant separation is missing.</a:t>
             </a:r>
           </a:p>
         </p:txBody>
@@ -16815,7 +16815,7 @@
                 </a:solidFill>
                 <a:latin typeface="Calibri"/>
               </a:rPr>
-              <a:t>—  White-label de marca y dominio.</a:t>
+              <a:t>—  White-label of brand and domain.</a:t>
             </a:r>
           </a:p>
         </p:txBody>
@@ -16854,7 +16854,7 @@
                 </a:solidFill>
                 <a:latin typeface="Calibri"/>
               </a:rPr>
-              <a:t>—  Stripe está como label en dropdowns pero no integrado de verdad. Pagos online aún no existen — todo es transferencia con confirmación.</a:t>
+              <a:t>—  Stripe is wired as a label in dropdowns but not actually integrated. Real online payments don't exist yet — everything is bank transfer with confirmation.</a:t>
             </a:r>
           </a:p>
         </p:txBody>
@@ -16893,7 +16893,7 @@
                 </a:solidFill>
                 <a:latin typeface="Calibri"/>
               </a:rPr>
-              <a:t>—  Asset Pack como abstracción explícita: hoy las reglas MH están dispersas en código; portarlas requiere refactor.</a:t>
+              <a:t>—  Asset Pack as an explicit abstraction: today the MH rules are scattered across the code; lifting them into a pack requires refactoring.</a:t>
             </a:r>
           </a:p>
         </p:txBody>
@@ -16932,7 +16932,7 @@
                 </a:solidFill>
                 <a:latin typeface="Calibri"/>
               </a:rPr>
-              <a:t>16  ·  ESTADO ACTUAL</a:t>
+              <a:t>16  ·  TODAY</a:t>
             </a:r>
           </a:p>
         </p:txBody>
@@ -16971,7 +16971,7 @@
                 </a:solidFill>
                 <a:latin typeface="Calibri"/>
               </a:rPr>
-              <a:t>PRODUCCIÓN REAL  ·  DEUDA EXPLÍCITA</a:t>
+              <a:t>REAL PRODUCTION  ·  EXPLICIT DEBT</a:t>
             </a:r>
           </a:p>
         </p:txBody>
@@ -17072,7 +17072,7 @@
                 </a:solidFill>
                 <a:latin typeface="Georgia"/>
               </a:rPr>
-              <a:t>En una frase</a:t>
+              <a:t>In one sentence</a:t>
             </a:r>
           </a:p>
         </p:txBody>
@@ -17111,7 +17111,7 @@
                 </a:solidFill>
                 <a:latin typeface="Calibri"/>
               </a:rPr>
-              <a:t>CIERRE</a:t>
+              <a:t>CLOSING</a:t>
             </a:r>
           </a:p>
         </p:txBody>
@@ -17220,7 +17220,7 @@
                 </a:solidFill>
                 <a:latin typeface="Georgia"/>
               </a:rPr>
-              <a:t>“Maninos OS es la disciplina operativa de un dealer especializado de mobile homes en Texas — convertida en código. Lo que era spreadsheet, WhatsApp, QuickBooks y procedimientos no escritos, ahora es un sistema con seis agentes de IA, GL propio, módulo de financiamiento, portal del cliente y audit log.”</a:t>
+              <a:t>“Maninos OS is the operational discipline of a specialized mobile-home dealer in Texas — turned into code. What used to be spreadsheets, WhatsApp, QuickBooks, and unwritten procedure is now a system with six AI agents, its own GL, an in-house financing module, a customer portal, and an audit log.”</a:t>
             </a:r>
           </a:p>
         </p:txBody>
@@ -17294,7 +17294,7 @@
                 </a:solidFill>
                 <a:latin typeface="Georgia"/>
               </a:rPr>
-              <a:t>El siguiente paso natural es separar el motor de las reglas específicas de Maninos, formalizar el concepto de Asset Pack, y permitir que otros dealers — primero de mobile homes en otros estados, después de RV o BHPH — corran sobre la misma infraestructura.</a:t>
+              <a:t>The natural next step is to separate the engine from Maninos's specific rules, formalize the Asset Pack abstraction, and let other dealers — first mobile homes in other states, then RV or BHPH — run on the same infrastructure.</a:t>
             </a:r>
           </a:p>
         </p:txBody>
@@ -17407,7 +17407,7 @@
                 </a:solidFill>
                 <a:latin typeface="Calibri"/>
               </a:rPr>
-              <a:t>Documento descriptivo · 2026</a:t>
+              <a:t>Descriptive document · 2026</a:t>
             </a:r>
           </a:p>
         </p:txBody>
@@ -17524,7 +17524,7 @@
                 </a:solidFill>
                 <a:latin typeface="Calibri"/>
               </a:rPr>
-              <a:t>17  ·  CIERRE</a:t>
+              <a:t>17  ·  CLOSING</a:t>
             </a:r>
           </a:p>
         </p:txBody>
@@ -17563,7 +17563,7 @@
                 </a:solidFill>
                 <a:latin typeface="Calibri"/>
               </a:rPr>
-              <a:t>FIN DEL DOCUMENTO</a:t>
+              <a:t>END OF DOCUMENT</a:t>
             </a:r>
           </a:p>
         </p:txBody>
@@ -17664,7 +17664,7 @@
                 </a:solidFill>
                 <a:latin typeface="Georgia"/>
               </a:rPr>
-              <a:t>La forma del sistema</a:t>
+              <a:t>The shape of the system</a:t>
             </a:r>
           </a:p>
         </p:txBody>
@@ -17703,7 +17703,7 @@
                 </a:solidFill>
                 <a:latin typeface="Calibri"/>
               </a:rPr>
-              <a:t>ARQUITECTURA</a:t>
+              <a:t>ARCHITECTURE</a:t>
             </a:r>
           </a:p>
         </p:txBody>
@@ -17777,7 +17777,7 @@
                 </a:solidFill>
                 <a:latin typeface="Georgia"/>
               </a:rPr>
-              <a:t>Tres portales que comparten una sola base de datos Postgres. No hay sincronización ni jobs de réplica entre ellos: lo que ocurre en operaciones se ve al instante en finanzas y en la cuenta del cliente.</a:t>
+              <a:t>Three portals sharing a single Postgres database. There is no sync layer or replication job between them: anything that happens in operations is immediately visible in finance and in the customer's account.</a:t>
             </a:r>
           </a:p>
         </p:txBody>
@@ -17929,7 +17929,7 @@
                 </a:solidFill>
                 <a:latin typeface="Calibri"/>
               </a:rPr>
-              <a:t>OPERACIONES INTERNAS</a:t>
+              <a:t>INTERNAL OPERATIONS</a:t>
             </a:r>
           </a:p>
         </p:txBody>
@@ -17968,7 +17968,7 @@
                 </a:solidFill>
                 <a:latin typeface="Calibri"/>
               </a:rPr>
-              <a:t>Para el equipo de Maninos. Inventario, renovación, fotos, contabilidad, comisiones, títulos, dashboards. Acceso por rol: treasury, operations, yard_manager, admin, comprador, vendedor.</a:t>
+              <a:t>For the Maninos team. Inventory, renovation, photos, accounting, commissions, titles, dashboards. Role-based access: treasury, operations, yard_manager, admin, buyer, seller.</a:t>
             </a:r>
           </a:p>
         </p:txBody>
@@ -18120,7 +18120,7 @@
                 </a:solidFill>
                 <a:latin typeface="Calibri"/>
               </a:rPr>
-              <a:t>FINANCIAMIENTO E INVERSORES</a:t>
+              <a:t>FINANCING AND INVESTORS</a:t>
             </a:r>
           </a:p>
         </p:txBody>
@@ -18159,7 +18159,7 @@
                 </a:solidFill>
                 <a:latin typeface="Calibri"/>
               </a:rPr>
-              <a:t>Para underwriters y partners financieros. Solicitudes RTO, contratos de arrendamiento con opción a compra, pagos mensuales, mora, KYC, capital de inversores, promissory notes, reportes mensuales.</a:t>
+              <a:t>For underwriters and finance partners. RTO applications, lease-with-purchase-option contracts, monthly payments, delinquency, KYC, investor capital, promissory notes, monthly reports.</a:t>
             </a:r>
           </a:p>
         </p:txBody>
@@ -18272,7 +18272,7 @@
                 </a:solidFill>
                 <a:latin typeface="Georgia"/>
               </a:rPr>
-              <a:t>Clientes</a:t>
+              <a:t>Customers</a:t>
             </a:r>
           </a:p>
         </p:txBody>
@@ -18311,7 +18311,7 @@
                 </a:solidFill>
                 <a:latin typeface="Calibri"/>
               </a:rPr>
-              <a:t>CARA PÚBLICA Y AUTOSERVICIO</a:t>
+              <a:t>PUBLIC-FACING AND SELF-SERVICE</a:t>
             </a:r>
           </a:p>
         </p:txBody>
@@ -18350,7 +18350,7 @@
                 </a:solidFill>
                 <a:latin typeface="Calibri"/>
               </a:rPr>
-              <a:t>Para el comprador. Catálogo público, simulador de RTO, solicitud de crédito, KYC con subida de documentos, firma electrónica del contrato, estado de cuenta y reporte de pagos.</a:t>
+              <a:t>For the buyer. Public catalog, RTO simulator, credit application, KYC with document upload, e-signature of the contract, account statement and payment reporting.</a:t>
             </a:r>
           </a:p>
         </p:txBody>
@@ -18498,7 +18498,7 @@
                 </a:solidFill>
                 <a:latin typeface="Calibri"/>
               </a:rPr>
-              <a:t>PÁGINAS EN HOMES</a:t>
+              <a:t>PAGES IN HOMES</a:t>
             </a:r>
           </a:p>
         </p:txBody>
@@ -18611,7 +18611,7 @@
                 </a:solidFill>
                 <a:latin typeface="Calibri"/>
               </a:rPr>
-              <a:t>PÁGINAS EN CAPITAL</a:t>
+              <a:t>PAGES IN CAPITAL</a:t>
             </a:r>
           </a:p>
         </p:txBody>
@@ -18724,7 +18724,7 @@
                 </a:solidFill>
                 <a:latin typeface="Calibri"/>
               </a:rPr>
-              <a:t>PÁGINAS EN CLIENTES</a:t>
+              <a:t>PAGES IN CUSTOMERS</a:t>
             </a:r>
           </a:p>
         </p:txBody>
@@ -18837,7 +18837,7 @@
                 </a:solidFill>
                 <a:latin typeface="Calibri"/>
               </a:rPr>
-              <a:t>TABLAS EN POSTGRES</a:t>
+              <a:t>TABLES IN POSTGRES</a:t>
             </a:r>
           </a:p>
         </p:txBody>
@@ -18950,7 +18950,7 @@
                 </a:solidFill>
                 <a:latin typeface="Calibri"/>
               </a:rPr>
-              <a:t>MIGRACIONES SQL</a:t>
+              <a:t>SQL MIGRATIONS</a:t>
             </a:r>
           </a:p>
         </p:txBody>
@@ -18989,7 +18989,7 @@
                 </a:solidFill>
                 <a:latin typeface="Calibri"/>
               </a:rPr>
-              <a:t>Cifras tomadas directamente del repositorio de Maninos a fecha de hoy.</a:t>
+              <a:t>Numbers taken directly from the Maninos repository, as of today.</a:t>
             </a:r>
           </a:p>
         </p:txBody>
@@ -19028,7 +19028,7 @@
                 </a:solidFill>
                 <a:latin typeface="Calibri"/>
               </a:rPr>
-              <a:t>02  ·  ARQUITECTURA</a:t>
+              <a:t>02  ·  ARCHITECTURE</a:t>
             </a:r>
           </a:p>
         </p:txBody>
@@ -19067,7 +19067,7 @@
                 </a:solidFill>
                 <a:latin typeface="Calibri"/>
               </a:rPr>
-              <a:t>TRES PORTALES  ·  UNA BASE DE DATOS</a:t>
+              <a:t>THREE PORTALS  ·  ONE DATABASE</a:t>
             </a:r>
           </a:p>
         </p:txBody>
@@ -19212,7 +19212,7 @@
                 </a:solidFill>
                 <a:latin typeface="Georgia"/>
               </a:rPr>
-              <a:t>— PARTE I —</a:t>
+              <a:t>— PART I —</a:t>
             </a:r>
           </a:p>
         </p:txBody>
@@ -19251,7 +19251,7 @@
                 </a:solidFill>
                 <a:latin typeface="Georgia"/>
               </a:rPr>
-              <a:t>El sistema, módulo por módulo</a:t>
+              <a:t>The system, module by module</a:t>
             </a:r>
           </a:p>
         </p:txBody>
@@ -19290,7 +19290,7 @@
                 </a:solidFill>
                 <a:latin typeface="Georgia"/>
               </a:rPr>
-              <a:t>Recorrido descriptivo por cada portal: qué incluye, cómo lo usa cada usuario, qué datos guarda y cómo se conecta al resto.</a:t>
+              <a:t>A descriptive walkthrough of each portal: what it includes, how each user works with it, what data it stores, and how it connects to the rest.</a:t>
             </a:r>
           </a:p>
         </p:txBody>
@@ -19391,7 +19391,7 @@
                 </a:solidFill>
                 <a:latin typeface="Georgia"/>
               </a:rPr>
-              <a:t>Portal Homes</a:t>
+              <a:t>Homes Portal</a:t>
             </a:r>
           </a:p>
         </p:txBody>
@@ -19430,7 +19430,7 @@
                 </a:solidFill>
                 <a:latin typeface="Calibri"/>
               </a:rPr>
-              <a:t>OPERACIONES INTERNAS</a:t>
+              <a:t>INTERNAL OPERATIONS</a:t>
             </a:r>
           </a:p>
         </p:txBody>
@@ -19543,7 +19543,7 @@
                 </a:solidFill>
                 <a:latin typeface="Georgia"/>
               </a:rPr>
-              <a:t>El día a día del staff</a:t>
+              <a:t>The staff's daily workspace</a:t>
             </a:r>
           </a:p>
         </p:txBody>
@@ -19582,7 +19582,7 @@
                 </a:solidFill>
                 <a:latin typeface="Calibri"/>
               </a:rPr>
-              <a:t>El staff de Maninos pasa la jornada en este portal. Accede por /homes/* tras autenticarse en Supabase con su rol asignado. La barra lateral muestra solo las secciones a las que tiene acceso, con un badge de pendientes (transferencias de título, órdenes de pago, aprobaciones de renovación).</a:t>
+              <a:t>The Maninos staff spends the workday in this portal. Access is at /homes/* after authenticating in Supabase with their assigned role. The sidebar only shows the sections they have access to, with a badge for pending items (title transfers, payment orders, renovation approvals).</a:t>
             </a:r>
           </a:p>
         </p:txBody>
@@ -19621,7 +19621,7 @@
                 </a:solidFill>
                 <a:latin typeface="Calibri"/>
               </a:rPr>
-              <a:t>SECCIÓN</a:t>
+              <a:t>SECTION</a:t>
             </a:r>
           </a:p>
         </p:txBody>
@@ -19660,7 +19660,7 @@
                 </a:solidFill>
                 <a:latin typeface="Calibri"/>
               </a:rPr>
-              <a:t>FUNCIÓN</a:t>
+              <a:t>FUNCTION</a:t>
             </a:r>
           </a:p>
         </p:txBody>
@@ -19773,7 +19773,7 @@
                 </a:solidFill>
                 <a:latin typeface="Calibri"/>
               </a:rPr>
-              <a:t>KPIs, mapa de Texas, gráfico de actividad de los últimos 6 meses, pipeline por estado de propiedad.</a:t>
+              <a:t>KPIs, Texas map, six-month activity chart, pipeline by property status.</a:t>
             </a:r>
           </a:p>
         </p:txBody>
@@ -19886,7 +19886,7 @@
                 </a:solidFill>
                 <a:latin typeface="Calibri"/>
               </a:rPr>
-              <a:t>Listado con filtros por estado (purchased, published, reserved, renovating, sold), búsqueda por dirección/código. Subrutas para edición, fotos, checklist “Revisar Casa” y wizard de renovación.</a:t>
+              <a:t>Listing with status filters (purchased, published, reserved, renovating, sold), search by address/code. Subroutes for editing, photos, the “Revisar Casa” checklist, and the renovation wizard.</a:t>
             </a:r>
           </a:p>
         </p:txBody>
@@ -19999,7 +19999,7 @@
                 </a:solidFill>
                 <a:latin typeface="Calibri"/>
               </a:rPr>
-              <a:t>Títulos en curso. Widget del scheduler diario contra TDHCA + modal para subida manual de títulos legacy. Cada serial es un link directo a la base TDHCA.</a:t>
+              <a:t>Titles in flight. Daily TDHCA scheduler widget plus a modal for manual upload of legacy titles. Each serial is a direct link to the TDHCA database.</a:t>
             </a:r>
           </a:p>
         </p:txBody>
@@ -20112,7 +20112,7 @@
                 </a:solidFill>
                 <a:latin typeface="Calibri"/>
               </a:rPr>
-              <a:t>Ventas activas, pagos parciales, comisiones (finder + closer), generación de Bill of Sale en PDF, redirección a Capital cuando es RTO.</a:t>
+              <a:t>Active sales, partial payments, commissions (finder + closer), Bill of Sale PDF generation, redirect to Capital when the sale is RTO.</a:t>
             </a:r>
           </a:p>
         </p:txBody>
@@ -20225,7 +20225,7 @@
                 </a:solidFill>
                 <a:latin typeface="Calibri"/>
               </a:rPr>
-              <a:t>CRM interno solo para clientes contado.</a:t>
+              <a:t>Internal CRM, cash buyers only.</a:t>
             </a:r>
           </a:p>
         </p:txBody>
@@ -20338,7 +20338,7 @@
                 </a:solidFill>
                 <a:latin typeface="Calibri"/>
               </a:rPr>
-              <a:t>11 pestañas: overview, transactions, invoices, statements, chart of accounts, properties, banks, budget, recurring, audit, estado de cuenta.</a:t>
+              <a:t>11 tabs: overview, transactions, invoices, statements, chart of accounts, properties, banks, budget, recurring, audit, account statement.</a:t>
             </a:r>
           </a:p>
         </p:txBody>
@@ -20451,7 +20451,7 @@
                 </a:solidFill>
                 <a:latin typeface="Calibri"/>
               </a:rPr>
-              <a:t>Comisiones por empleado. Treasury y Admin ven todas; otros roles solo las propias.</a:t>
+              <a:t>Per-employee commissions. Treasury and Admin see all; other roles see only their own.</a:t>
             </a:r>
           </a:p>
         </p:txBody>
@@ -20564,7 +20564,7 @@
                 </a:solidFill>
                 <a:latin typeface="Calibri"/>
               </a:rPr>
-              <a:t>Listings externos scrapeados de fuentes públicas.</a:t>
+              <a:t>External listings scraped from public sources.</a:t>
             </a:r>
           </a:p>
         </p:txBody>
@@ -20638,7 +20638,7 @@
                 </a:solidFill>
                 <a:latin typeface="Calibri"/>
               </a:rPr>
-              <a:t>03  ·  PORTAL HOMES</a:t>
+              <a:t>03  ·  HOMES PORTAL</a:t>
             </a:r>
           </a:p>
         </p:txBody>
@@ -20677,7 +20677,7 @@
                 </a:solidFill>
                 <a:latin typeface="Calibri"/>
               </a:rPr>
-              <a:t>18 PÁGINAS  ·  ACCESO POR ROL</a:t>
+              <a:t>18 PAGES  ·  ROLE-BASED ACCESS</a:t>
             </a:r>
           </a:p>
         </p:txBody>
@@ -20778,7 +20778,7 @@
                 </a:solidFill>
                 <a:latin typeface="Georgia"/>
               </a:rPr>
-              <a:t>Portal Capital</a:t>
+              <a:t>Capital Portal</a:t>
             </a:r>
           </a:p>
         </p:txBody>
@@ -20817,7 +20817,7 @@
                 </a:solidFill>
                 <a:latin typeface="Calibri"/>
               </a:rPr>
-              <a:t>FINANCIAMIENTO PROPIO + INVERSORES</a:t>
+              <a:t>IN-HOUSE FINANCING + INVESTORS</a:t>
             </a:r>
           </a:p>
         </p:txBody>
@@ -20930,7 +20930,7 @@
                 </a:solidFill>
                 <a:latin typeface="Georgia"/>
               </a:rPr>
-              <a:t>El dealer como banco</a:t>
+              <a:t>The dealer as a bank</a:t>
             </a:r>
           </a:p>
         </p:txBody>
@@ -20969,7 +20969,7 @@
                 </a:solidFill>
                 <a:latin typeface="Calibri"/>
               </a:rPr>
-              <a:t>Cuando los bancos no financian — y para mobile homes pre-owned casi nunca lo hacen — el dealer se convierte en el prestamista. Capital es el portal donde se administra esa función. El acceso está restringido a un grupo reducido de personas autorizadas.</a:t>
+              <a:t>When banks won't finance — and for pre-owned mobile homes they almost never do — the dealer becomes the lender. Capital is the portal where that role is administered. Access is restricted to a small group of authorized people.</a:t>
             </a:r>
           </a:p>
         </p:txBody>
@@ -21008,7 +21008,7 @@
                 </a:solidFill>
                 <a:latin typeface="Calibri"/>
               </a:rPr>
-              <a:t>SECCIÓN</a:t>
+              <a:t>SECTION</a:t>
             </a:r>
           </a:p>
         </p:txBody>
@@ -21047,7 +21047,7 @@
                 </a:solidFill>
                 <a:latin typeface="Calibri"/>
               </a:rPr>
-              <a:t>FUNCIÓN</a:t>
+              <a:t>FUNCTION</a:t>
             </a:r>
           </a:p>
         </p:txBody>
@@ -21160,7 +21160,7 @@
                 </a:solidFill>
                 <a:latin typeface="Calibri"/>
               </a:rPr>
-              <a:t>Resumen de cartera, salud financiera, actividad reciente, KPIs.</a:t>
+              <a:t>Portfolio summary, financial health, recent activity, KPIs.</a:t>
             </a:r>
           </a:p>
         </p:txBody>
@@ -21273,7 +21273,7 @@
                 </a:solidFill>
                 <a:latin typeface="Calibri"/>
               </a:rPr>
-              <a:t>Solicitudes RTO en cada estado: pending, under review, approved, rejected, needs_info. Underwriting + scoring.</a:t>
+              <a:t>RTO applications in each state: pending, under review, approved, rejected, needs_info. Underwriting + scoring.</a:t>
             </a:r>
           </a:p>
         </p:txBody>
@@ -21386,7 +21386,7 @@
                 </a:solidFill>
                 <a:latin typeface="Calibri"/>
               </a:rPr>
-              <a:t>Verificación manual de identidad. Documentos subidos por el cliente al bucket de Supabase, revisados aquí. Sin servicio externo.</a:t>
+              <a:t>Manual customer identity verification. Documents uploaded by the client to the Supabase bucket and reviewed here. No external service.</a:t>
             </a:r>
           </a:p>
         </p:txBody>
@@ -21499,7 +21499,7 @@
                 </a:solidFill>
                 <a:latin typeface="Calibri"/>
               </a:rPr>
-              <a:t>Contratos RTO con sus 33 cláusulas, tabla de amortización, tracking de down payment por cuotas, generación de PDF.</a:t>
+              <a:t>RTO contracts with their 33 clauses, amortization table, down-payment installment tracking, PDF generation.</a:t>
             </a:r>
           </a:p>
         </p:txBody>
@@ -21612,7 +21612,7 @@
                 </a:solidFill>
                 <a:latin typeface="Calibri"/>
               </a:rPr>
-              <a:t>Pagos mensuales, confirmación de transferencias reportadas por el cliente, mora summary, comisiones, alertas de seguro vencido.</a:t>
+              <a:t>Monthly payments, confirmation of client-reported transfers, delinquency summary, commissions, insurance expiration alerts.</a:t>
             </a:r>
           </a:p>
         </p:txBody>
@@ -21725,7 +21725,7 @@
                 </a:solidFill>
                 <a:latin typeface="Calibri"/>
               </a:rPr>
-              <a:t>Inversores activos, capital comprometido, capital desplegado, retornos.</a:t>
+              <a:t>Active investors, committed capital, deployed capital, returns.</a:t>
             </a:r>
           </a:p>
         </p:txBody>
@@ -21838,7 +21838,7 @@
                 </a:solidFill>
                 <a:latin typeface="Calibri"/>
               </a:rPr>
-              <a:t>Pagarés de inversores con alertas de maturity a 90, 60 y 30 días.</a:t>
+              <a:t>Investor notes with maturity alerts at 90, 60, and 30 days.</a:t>
             </a:r>
           </a:p>
         </p:txBody>
@@ -21951,7 +21951,7 @@
                 </a:solidFill>
                 <a:latin typeface="Calibri"/>
               </a:rPr>
-              <a:t>Contabilidad propia de Capital: chart of accounts, asientos, estados bancarios con reconciliación, reportes (P&amp;L, balance, flujo de caja).</a:t>
+              <a:t>Capital's own accounting: chart of accounts, journal entries, bank statements with reconciliation, reports (P&amp;L, balance sheet, cash flow).</a:t>
             </a:r>
           </a:p>
         </p:txBody>
@@ -22064,7 +22064,7 @@
                 </a:solidFill>
                 <a:latin typeface="Calibri"/>
               </a:rPr>
-              <a:t>Estados mensuales en PDF para cada inversor + resúmenes unificados de cartera.</a:t>
+              <a:t>Monthly PDF statements for each investor plus unified portfolio summaries.</a:t>
             </a:r>
           </a:p>
         </p:txBody>
@@ -22138,7 +22138,7 @@
                 </a:solidFill>
                 <a:latin typeface="Calibri"/>
               </a:rPr>
-              <a:t>Mora</a:t>
+              <a:t>Delinquency</a:t>
             </a:r>
           </a:p>
         </p:txBody>
@@ -22177,7 +22177,7 @@
                 </a:solidFill>
                 <a:latin typeface="Calibri"/>
               </a:rPr>
-              <a:t>Cartera vencida por aging bucket (0–30, 31–60, 61–90, 90+).</a:t>
+              <a:t>Past-due portfolio by aging bucket (0–30, 31–60, 61–90, 90+).</a:t>
             </a:r>
           </a:p>
         </p:txBody>
@@ -22251,7 +22251,7 @@
                 </a:solidFill>
                 <a:latin typeface="Calibri"/>
               </a:rPr>
-              <a:t>04  ·  PORTAL CAPITAL</a:t>
+              <a:t>04  ·  CAPITAL PORTAL</a:t>
             </a:r>
           </a:p>
         </p:txBody>
@@ -22290,7 +22290,7 @@
                 </a:solidFill>
                 <a:latin typeface="Calibri"/>
               </a:rPr>
-              <a:t>19 PÁGINAS  ·  13 ARCHIVOS DE RUTAS BACKEND</a:t>
+              <a:t>19 PAGES  ·  13 BACKEND ROUTE FILES</a:t>
             </a:r>
           </a:p>
         </p:txBody>
@@ -22391,7 +22391,7 @@
                 </a:solidFill>
                 <a:latin typeface="Georgia"/>
               </a:rPr>
-              <a:t>Portal Clientes</a:t>
+              <a:t>Customers Portal</a:t>
             </a:r>
           </a:p>
         </p:txBody>
@@ -22430,7 +22430,7 @@
                 </a:solidFill>
                 <a:latin typeface="Calibri"/>
               </a:rPr>
-              <a:t>CARA PÚBLICA Y AUTOSERVICIO</a:t>
+              <a:t>PUBLIC-FACING AND SELF-SERVICE</a:t>
             </a:r>
           </a:p>
         </p:txBody>
@@ -22543,7 +22543,7 @@
                 </a:solidFill>
                 <a:latin typeface="Georgia"/>
               </a:rPr>
-              <a:t>Del primer click al pago 36</a:t>
+              <a:t>From first click to payment 36</a:t>
             </a:r>
           </a:p>
         </p:txBody>
@@ -22582,7 +22582,7 @@
                 </a:solidFill>
                 <a:latin typeface="Calibri"/>
               </a:rPr>
-              <a:t>Es el único portal accesible sin sesión. Un visitante puede llegar al catálogo desde Facebook o desde un link directo. La autenticación aparece solo al avanzar en el embudo de compra.</a:t>
+              <a:t>This is the only portal accessible without a session. A visitor can land on the catalog from Facebook or from a direct link. Authentication only appears as the buyer advances through the funnel.</a:t>
             </a:r>
           </a:p>
         </p:txBody>
@@ -22621,7 +22621,7 @@
                 </a:solidFill>
                 <a:latin typeface="Calibri"/>
               </a:rPr>
-              <a:t>CAMINO DEL VISITANTE</a:t>
+              <a:t>VISITOR'S PATH</a:t>
             </a:r>
           </a:p>
         </p:txBody>
@@ -22769,7 +22769,7 @@
                 </a:solidFill>
                 <a:latin typeface="Georgia"/>
               </a:rPr>
-              <a:t>Catálogo</a:t>
+              <a:t>Catalog</a:t>
             </a:r>
           </a:p>
         </p:txBody>
@@ -22808,7 +22808,7 @@
                 </a:solidFill>
                 <a:latin typeface="Calibri"/>
               </a:rPr>
-              <a:t>Listado público con filtros por ciudad y precio. Auto-refresh cada 2 min.</a:t>
+              <a:t>Public listing with city and price filters. Auto-refreshes every 2 min to surface new inventory.</a:t>
             </a:r>
           </a:p>
         </p:txBody>
@@ -22921,7 +22921,7 @@
                 </a:solidFill>
                 <a:latin typeface="Georgia"/>
               </a:rPr>
-              <a:t>Propiedad</a:t>
+              <a:t>Property</a:t>
             </a:r>
           </a:p>
         </p:txBody>
@@ -22960,7 +22960,7 @@
                 </a:solidFill>
                 <a:latin typeface="Calibri"/>
               </a:rPr>
-              <a:t>Detalle con galería, especificaciones y simulador RTO interactivo (down 30–100%, plazo 12–60 meses).</a:t>
+              <a:t>Detail page with gallery, specs, and an interactive RTO simulator (down 30–100%, term 12–60 months).</a:t>
             </a:r>
           </a:p>
         </p:txBody>
@@ -23073,7 +23073,7 @@
                 </a:solidFill>
                 <a:latin typeface="Georgia"/>
               </a:rPr>
-              <a:t>Compra</a:t>
+              <a:t>Purchase</a:t>
             </a:r>
           </a:p>
         </p:txBody>
@@ -23112,7 +23112,7 @@
                 </a:solidFill>
                 <a:latin typeface="Calibri"/>
               </a:rPr>
-              <a:t>Captura contacto, crea cliente o reusa existente, elige método: contado o RTO.</a:t>
+              <a:t>Captures contact, creates client or reuses existing one, picks method: cash or RTO.</a:t>
             </a:r>
           </a:p>
         </p:txBody>
@@ -23225,7 +23225,7 @@
                 </a:solidFill>
                 <a:latin typeface="Georgia"/>
               </a:rPr>
-              <a:t>Cuenta</a:t>
+              <a:t>Account</a:t>
             </a:r>
           </a:p>
         </p:txBody>
@@ -23264,7 +23264,7 @@
                 </a:solidFill>
                 <a:latin typeface="Calibri"/>
               </a:rPr>
-              <a:t>Estado de cuenta, KYC, firma de contrato, documentos, reportar pagos mensuales.</a:t>
+              <a:t>Account statement, KYC, contract signing, documents, monthly payment reporting.</a:t>
             </a:r>
           </a:p>
         </p:txBody>
@@ -23303,7 +23303,7 @@
                 </a:solidFill>
                 <a:latin typeface="Calibri"/>
               </a:rPr>
-              <a:t>LO QUE EL CLIENTE PUEDE HACER EN SU CUENTA</a:t>
+              <a:t>WHAT THE CUSTOMER CAN DO IN THEIR ACCOUNT</a:t>
             </a:r>
           </a:p>
         </p:txBody>
@@ -23342,7 +23342,7 @@
                 </a:solidFill>
                 <a:latin typeface="Calibri"/>
               </a:rPr>
-              <a:t>—  Subir su licencia, pasaporte o ID estatal para KYC (JPG/PNG/WebP/HEIC, máx 10 MB)</a:t>
+              <a:t>—  Upload their driver's license, passport, or state ID for KYC (JPG/PNG/WebP/HEIC, up to 10 MB)</a:t>
             </a:r>
           </a:p>
         </p:txBody>
@@ -23381,7 +23381,7 @@
                 </a:solidFill>
                 <a:latin typeface="Calibri"/>
               </a:rPr>
-              <a:t>—  Firmar electrónicamente su contrato RTO con sello de tiempo, IP y user-agent registrados</a:t>
+              <a:t>—  Electronically sign their RTO contract with timestamp, IP, and user-agent recorded</a:t>
             </a:r>
           </a:p>
         </p:txBody>
@@ -23420,7 +23420,7 @@
                 </a:solidFill>
                 <a:latin typeface="Calibri"/>
               </a:rPr>
-              <a:t>—  Completar la solicitud de crédito en secciones (empleo, vivienda, activos, deudas, referencias)</a:t>
+              <a:t>—  Complete the credit application in sections (employment, housing, assets, debts, references)</a:t>
             </a:r>
           </a:p>
         </p:txBody>
@@ -23459,7 +23459,7 @@
                 </a:solidFill>
                 <a:latin typeface="Calibri"/>
               </a:rPr>
-              <a:t>—  Reportar el pago mensual del mes en curso y ver el historial completo de pagos</a:t>
+              <a:t>—  Report the current month's payment and review the full payment history</a:t>
             </a:r>
           </a:p>
         </p:txBody>
@@ -23498,7 +23498,7 @@
                 </a:solidFill>
                 <a:latin typeface="Calibri"/>
               </a:rPr>
-              <a:t>—  Descargar contratos firmados y documentos de transferencia de título</a:t>
+              <a:t>—  Download signed contracts and title transfer documents</a:t>
             </a:r>
           </a:p>
         </p:txBody>
@@ -23537,7 +23537,7 @@
                 </a:solidFill>
                 <a:latin typeface="Calibri"/>
               </a:rPr>
-              <a:t>05  ·  PORTAL CLIENTES</a:t>
+              <a:t>05  ·  CUSTOMERS PORTAL</a:t>
             </a:r>
           </a:p>
         </p:txBody>
@@ -23576,7 +23576,7 @@
                 </a:solidFill>
                 <a:latin typeface="Calibri"/>
               </a:rPr>
-              <a:t>16 PÁGINAS  ·  PÚBLICO + AUTENTICADO</a:t>
+              <a:t>16 PAGES  ·  PUBLIC + AUTHENTICATED</a:t>
             </a:r>
           </a:p>
         </p:txBody>
@@ -23721,7 +23721,7 @@
                 </a:solidFill>
                 <a:latin typeface="Georgia"/>
               </a:rPr>
-              <a:t>— PARTE II —</a:t>
+              <a:t>— PART II —</a:t>
             </a:r>
           </a:p>
         </p:txBody>
@@ -23760,7 +23760,7 @@
                 </a:solidFill>
                 <a:latin typeface="Georgia"/>
               </a:rPr>
-              <a:t>El loop de negocio</a:t>
+              <a:t>The business loop</a:t>
             </a:r>
           </a:p>
         </p:txBody>
@@ -23799,7 +23799,7 @@
                 </a:solidFill>
                 <a:latin typeface="Georgia"/>
               </a:rPr>
-              <a:t>Cómo se mueve un activo desde que aparece en una fuente externa hasta que termina su contrato RTO 36 meses después.</a:t>
+              <a:t>How an asset moves from the moment it surfaces in an external source until its 36-month RTO contract closes out.</a:t>
             </a:r>
           </a:p>
         </p:txBody>
@@ -23900,7 +23900,7 @@
                 </a:solidFill>
                 <a:latin typeface="Georgia"/>
               </a:rPr>
-              <a:t>Comprar · Renovar · Vender · Cobrar</a:t>
+              <a:t>Buy · Renovate · Sell · Collect</a:t>
             </a:r>
           </a:p>
         </p:txBody>
@@ -23939,7 +23939,7 @@
                 </a:solidFill>
                 <a:latin typeface="Calibri"/>
               </a:rPr>
-              <a:t>EL LOOP COMPLETO</a:t>
+              <a:t>THE FULL LOOP</a:t>
             </a:r>
           </a:p>
         </p:txBody>
@@ -24013,7 +24013,7 @@
                 </a:solidFill>
                 <a:latin typeface="Calibri"/>
               </a:rPr>
-              <a:t>Cada etapa tiene su tabla, su(s) agente(s) de IA y su superficie de UI. Un mismo registro avanza por las cinco etapas sin salir del sistema y sin re-tipear datos.</a:t>
+              <a:t>Each stage has its tables, its AI agent(s), and its UI surface. The same record advances through five stages without leaving the system and without anyone retyping data.</a:t>
             </a:r>
           </a:p>
         </p:txBody>
@@ -24052,7 +24052,7 @@
                 </a:solidFill>
                 <a:latin typeface="Calibri"/>
               </a:rPr>
-              <a:t>ETAPA</a:t>
+              <a:t>STAGE</a:t>
             </a:r>
           </a:p>
         </p:txBody>
@@ -24091,7 +24091,7 @@
                 </a:solidFill>
                 <a:latin typeface="Calibri"/>
               </a:rPr>
-              <a:t>QUÉ OCURRE</a:t>
+              <a:t>WHAT HAPPENS</a:t>
             </a:r>
           </a:p>
         </p:txBody>
@@ -24130,7 +24130,7 @@
                 </a:solidFill>
                 <a:latin typeface="Calibri"/>
               </a:rPr>
-              <a:t>AGENTES / SERVICIOS</a:t>
+              <a:t>AGENTS / SERVICES</a:t>
             </a:r>
           </a:p>
         </p:txBody>
@@ -24169,7 +24169,7 @@
                 </a:solidFill>
                 <a:latin typeface="Calibri"/>
               </a:rPr>
-              <a:t>DATOS QUE PRODUCE</a:t>
+              <a:t>DATA PRODUCED</a:t>
             </a:r>
           </a:p>
         </p:txBody>
@@ -24243,7 +24243,7 @@
                 </a:solidFill>
                 <a:latin typeface="Calibri"/>
               </a:rPr>
-              <a:t>1. Detectar</a:t>
+              <a:t>1. Detect</a:t>
             </a:r>
           </a:p>
         </p:txBody>
@@ -24282,7 +24282,7 @@
                 </a:solidFill>
                 <a:latin typeface="Calibri"/>
               </a:rPr>
-              <a:t>BuscadorAgent recorre fuentes externas, aplica reglas de Maninos, propone candidatos.</a:t>
+              <a:t>BuscadorAgent crawls external sources, applies Maninos's rules, proposes candidates.</a:t>
             </a:r>
           </a:p>
         </p:txBody>
@@ -24321,7 +24321,7 @@
                 </a:solidFill>
                 <a:latin typeface="Calibri"/>
               </a:rPr>
-              <a:t>BuscadorAgent (Playwright + scrapers MHVillage, MobileHome.net, Zillow, FB Marketplace).</a:t>
+              <a:t>BuscadorAgent (Playwright + scrapers for MHVillage, MobileHome.net, Zillow, FB Marketplace).</a:t>
             </a:r>
           </a:p>
         </p:txBody>
@@ -24434,7 +24434,7 @@
                 </a:solidFill>
                 <a:latin typeface="Calibri"/>
               </a:rPr>
-              <a:t>2. Comprar</a:t>
+              <a:t>2. Buy</a:t>
             </a:r>
           </a:p>
         </p:txBody>
@@ -24473,7 +24473,7 @@
                 </a:solidFill>
                 <a:latin typeface="Calibri"/>
               </a:rPr>
-              <a:t>Wizard “Revisar Casa”: fotos, checklist, datos del seller, oferta.</a:t>
+              <a:t>“Revisar Casa” wizard: photos, checklist, seller details, offer.</a:t>
             </a:r>
           </a:p>
         </p:txBody>
@@ -24512,7 +24512,7 @@
                 </a:solidFill>
                 <a:latin typeface="Calibri"/>
               </a:rPr>
-              <a:t>FotosAgent (clasifica imágenes), VozAgent (notas dictadas en el yard).</a:t>
+              <a:t>FotosAgent (image classification), VozAgent (notes dictated on the yard).</a:t>
             </a:r>
           </a:p>
         </p:txBody>
@@ -24625,7 +24625,7 @@
                 </a:solidFill>
                 <a:latin typeface="Calibri"/>
               </a:rPr>
-              <a:t>3. Renovar</a:t>
+              <a:t>3. Renovate</a:t>
             </a:r>
           </a:p>
         </p:txBody>
@@ -24664,7 +24664,7 @@
                 </a:solidFill>
                 <a:latin typeface="Calibri"/>
               </a:rPr>
-              <a:t>Plan de renovación: materiales, mano de obra, contingencia.</a:t>
+              <a:t>Renovation plan: materials, labor, contingency.</a:t>
             </a:r>
           </a:p>
         </p:txBody>
@@ -24703,7 +24703,7 @@
                 </a:solidFill>
                 <a:latin typeface="Calibri"/>
               </a:rPr>
-              <a:t>RenovacionAgent (orquestador), CostosAgent (precios desde DB).</a:t>
+              <a:t>RenovacionAgent (orchestrator), CostosAgent (prices read from DB).</a:t>
             </a:r>
           </a:p>
         </p:txBody>
@@ -24816,7 +24816,7 @@
                 </a:solidFill>
                 <a:latin typeface="Calibri"/>
               </a:rPr>
-              <a:t>4. Listar y vender</a:t>
+              <a:t>4. List and sell</a:t>
             </a:r>
           </a:p>
         </p:txBody>
@@ -24855,7 +24855,7 @@
                 </a:solidFill>
                 <a:latin typeface="Calibri"/>
               </a:rPr>
-              <a:t>Precio sugerido. Publicación. Cliente compra contado o solicita RTO.</a:t>
+              <a:t>Suggested price. Publishing. Customer buys cash or applies for RTO.</a:t>
             </a:r>
           </a:p>
         </p:txBody>
@@ -24894,7 +24894,7 @@
                 </a:solidFill>
                 <a:latin typeface="Calibri"/>
               </a:rPr>
-              <a:t>PrecioAgent (techo 80% del valor de mercado).</a:t>
+              <a:t>PrecioAgent (80% market-value ceiling).</a:t>
             </a:r>
           </a:p>
         </p:txBody>
@@ -25007,7 +25007,7 @@
                 </a:solidFill>
                 <a:latin typeface="Calibri"/>
               </a:rPr>
-              <a:t>5. Cobrar y cerrar</a:t>
+              <a:t>5. Collect and close</a:t>
             </a:r>
           </a:p>
         </p:txBody>
@@ -25046,7 +25046,7 @@
                 </a:solidFill>
                 <a:latin typeface="Calibri"/>
               </a:rPr>
-              <a:t>Pagos mensuales, late fees, mora, transferencia final de título.</a:t>
+              <a:t>Monthly payments, late fees, delinquency, final title transfer.</a:t>
             </a:r>
           </a:p>
         </p:txBody>
@@ -25085,7 +25085,7 @@
                 </a:solidFill>
                 <a:latin typeface="Calibri"/>
               </a:rPr>
-              <a:t>Scheduler title_monitor diario contra TDHCA. Email service para recordatorios.</a:t>
+              <a:t>Daily title_monitor scheduler against TDHCA. Email service for reminders.</a:t>
             </a:r>
           </a:p>
         </p:txBody>
@@ -25198,7 +25198,7 @@
                 </a:solidFill>
                 <a:latin typeface="Calibri"/>
               </a:rPr>
-              <a:t>06  ·  EL LOOP</a:t>
+              <a:t>06  ·  THE LOOP</a:t>
             </a:r>
           </a:p>
         </p:txBody>
@@ -25237,7 +25237,7 @@
                 </a:solidFill>
                 <a:latin typeface="Calibri"/>
               </a:rPr>
-              <a:t>5 ETAPAS  ·  6 AGENTES  ·  UNA FUENTE DE VERDAD</a:t>
+              <a:t>5 STAGES  ·  6 AGENTS  ·  ONE SOURCE OF TRUTH</a:t>
             </a:r>
           </a:p>
         </p:txBody>

</xml_diff>